<commit_message>
docs: place Mooncake and KV beside the Ascend inference paths
Show in-engine KV, cross-instance connectors, and Mooncake Conductor/Store without making them a call-stack layer.

Co-authored-by: 69515164-rgb <69515164-rgb@users.noreply.github.com>
</commit_message>
<xml_diff>
--- a/docs/ascend-infer-stack.pptx
+++ b/docs/ascend-infer-stack.pptx
@@ -502,7 +502,7 @@
           <a:lstStyle/>
           <a:p>
             <a:r>
-              <a:t>依据 MindIE 3.1 用户手册 Overview 与 MindIE Motor 3.1 架构说明。MindIE LLM 进入维护，官方建议新部署使用 MindIE Motor 加 vLLM-Ascend。MindIE LLM 自上而下为 Server、LLM Manager、Text Generator、Modeling。LLM Manager 内的 Engine 编排 Scheduler、Executor 和 Worker；Block Manager 管 KV 池。Executor 把调度结果下发给 Text Generator，覆盖跨节点、跨设备。Text Generator 含前处理、Generator、Sampler，并支持可插拔的并行解码。Modeling 提供 ATB Models；开发者架构说明同时支持 ACLGraph 和 ATBGraph。Motor：Coordinator 为数据面入口；Controller 与 NodeManager 为管控面；EngineServer 北向接二者，南向当前仅 vLLM。架构页写明南向接口包括 vLLM、SGLang 和 MindIE，当前版本只支持 vLLM。MindCluster 提供 Kubernetes、PD 分离 CRD 和 Operator，位于调用链外侧。CCAE 可选。CANN 组成沿用方案概述：AscendCL、GE、Runtime、算子库、HCCL、DVPP。推理运行包为 NNRT。</a:t>
+              <a:t>依据 MindIE 3.1 用户手册 Overview 与 MindIE Motor 3.1 架构说明。MindIE LLM 进入维护，官方建议新部署使用 MindIE Motor 加 vLLM-Ascend。MindIE LLM 自上而下为 Server、LLM Manager、Text Generator、Modeling。LLM Manager 内的 Engine 编排 Scheduler、Executor 和 Worker；Block Manager 管 KV 池。Executor 把调度结果下发给 Text Generator，覆盖跨节点、跨设备。Text Generator 含前处理、Generator、Sampler，并支持可插拔的并行解码。Modeling 提供 ATB Models；开发者架构说明同时支持 ACLGraph 和 ATBGraph。Motor：Coordinator 为数据面入口；Controller 与 NodeManager 为管控面；EngineServer 北向接二者，南向当前仅 vLLM。架构页写明南向接口包括 vLLM、SGLang 和 MindIE，当前版本只支持 vLLM。MindCluster 提供 Kubernetes、PD 分离 CRD 和 Operator，位于调用链外侧。CCAE 可选。CANN 组成沿用方案概述：AscendCL、GE、Runtime、算子库、HCCL、DVPP。推理运行包为 NNRT。KV：MindIE LLM 的 Block Manager 管 DP 内 KV，kv connector 对接池化后端，Mooncake 是其中一种 backend。Motor 的亲和调度依赖 Mooncake Conductor：P 实例用 ZMQ 发布 KV 事件，Coordinator 按位置调度。3.1 中文页写优先送到已缓存该 KV 的 D 实例；英文页写优先送到已有前缀 KV 的 P 实例。图上只写按位置调度。Motor 的 KV 池基于 vLLM-Ascend：MultiConnector 把 MooncakeConnector 与 AscendStoreConnector 组合。Mooncake Store 由 mooncake_master 管理；另一后端是 MemCache。Conductor 设计里还可接 YuanRong。共享池推入可以使用按层 connector。亲和调度文档建议此时不要再按层单独传输，由 Conductor 管全局位置。</a:t>
             </a:r>
           </a:p>
         </p:txBody>
@@ -3873,8 +3873,8 @@
         </p:nvSpPr>
         <p:spPr>
           <a:xfrm>
-            <a:off x="256032" y="1700784"/>
-            <a:ext cx="841248" cy="2944368"/>
+            <a:off x="256032" y="1645920"/>
+            <a:ext cx="841248" cy="2468880"/>
           </a:xfrm>
           <a:prstGeom prst="rect">
             <a:avLst/>
@@ -3915,8 +3915,8 @@
         </p:nvSpPr>
         <p:spPr>
           <a:xfrm>
-            <a:off x="1133856" y="1700784"/>
-            <a:ext cx="5321808" cy="2944368"/>
+            <a:off x="1133856" y="1645920"/>
+            <a:ext cx="5321808" cy="2468880"/>
           </a:xfrm>
           <a:prstGeom prst="rect">
             <a:avLst/>
@@ -3960,7 +3960,7 @@
         </p:nvSpPr>
         <p:spPr>
           <a:xfrm>
-            <a:off x="1133856" y="1700784"/>
+            <a:off x="1133856" y="1645920"/>
             <a:ext cx="5321808" cy="310896"/>
           </a:xfrm>
           <a:prstGeom prst="rect">
@@ -4021,8 +4021,8 @@
         </p:nvSpPr>
         <p:spPr>
           <a:xfrm>
-            <a:off x="1207008" y="2084832"/>
-            <a:ext cx="1627632" cy="580644"/>
+            <a:off x="1207008" y="2029968"/>
+            <a:ext cx="1627632" cy="461772"/>
           </a:xfrm>
           <a:prstGeom prst="rect">
             <a:avLst/>
@@ -4082,8 +4082,8 @@
         </p:nvSpPr>
         <p:spPr>
           <a:xfrm>
-            <a:off x="2834640" y="2084832"/>
-            <a:ext cx="3547872" cy="580644"/>
+            <a:off x="2834640" y="2029968"/>
+            <a:ext cx="3547872" cy="461772"/>
           </a:xfrm>
           <a:prstGeom prst="rect">
             <a:avLst/>
@@ -4125,8 +4125,8 @@
         </p:nvSpPr>
         <p:spPr>
           <a:xfrm>
-            <a:off x="2926080" y="2084832"/>
-            <a:ext cx="3419856" cy="580644"/>
+            <a:off x="2926080" y="2029968"/>
+            <a:ext cx="3419856" cy="461772"/>
           </a:xfrm>
           <a:prstGeom prst="rect">
             <a:avLst/>
@@ -4154,7 +4154,7 @@
                 <a:ea typeface="Microsoft YaHei"/>
                 <a:cs typeface="Microsoft YaHei"/>
               </a:rPr>
-              <a:t>服务入口。Endpoint 兼容 OpenAI、vLLM、Triton、TGI。</a:t>
+              <a:t>Endpoint 兼容 OpenAI、vLLM、Triton、TGI。</a:t>
             </a:r>
           </a:p>
         </p:txBody>
@@ -4167,8 +4167,8 @@
         </p:nvSpPr>
         <p:spPr>
           <a:xfrm>
-            <a:off x="1207008" y="2720340"/>
-            <a:ext cx="1627632" cy="580644"/>
+            <a:off x="1207008" y="2546604"/>
+            <a:ext cx="1627632" cy="461772"/>
           </a:xfrm>
           <a:prstGeom prst="rect">
             <a:avLst/>
@@ -4228,8 +4228,8 @@
         </p:nvSpPr>
         <p:spPr>
           <a:xfrm>
-            <a:off x="2834640" y="2720340"/>
-            <a:ext cx="3547872" cy="580644"/>
+            <a:off x="2834640" y="2546604"/>
+            <a:ext cx="3547872" cy="461772"/>
           </a:xfrm>
           <a:prstGeom prst="rect">
             <a:avLst/>
@@ -4271,8 +4271,8 @@
         </p:nvSpPr>
         <p:spPr>
           <a:xfrm>
-            <a:off x="2926080" y="2720340"/>
-            <a:ext cx="3419856" cy="580644"/>
+            <a:off x="2926080" y="2546604"/>
+            <a:ext cx="3419856" cy="461772"/>
           </a:xfrm>
           <a:prstGeom prst="rect">
             <a:avLst/>
@@ -4300,7 +4300,7 @@
                 <a:ea typeface="Microsoft YaHei"/>
                 <a:cs typeface="Microsoft YaHei"/>
               </a:rPr>
-              <a:t>请求调度与 KV 池。Engine 内含 Scheduler、Block Manager。</a:t>
+              <a:t>连续组批。Engine 内含 Scheduler。</a:t>
             </a:r>
           </a:p>
         </p:txBody>
@@ -4313,8 +4313,8 @@
         </p:nvSpPr>
         <p:spPr>
           <a:xfrm>
-            <a:off x="1207008" y="3355848"/>
-            <a:ext cx="1627632" cy="580644"/>
+            <a:off x="1207008" y="3063240"/>
+            <a:ext cx="1627632" cy="461772"/>
           </a:xfrm>
           <a:prstGeom prst="rect">
             <a:avLst/>
@@ -4374,8 +4374,8 @@
         </p:nvSpPr>
         <p:spPr>
           <a:xfrm>
-            <a:off x="2834640" y="3355848"/>
-            <a:ext cx="3547872" cy="580644"/>
+            <a:off x="2834640" y="3063240"/>
+            <a:ext cx="3547872" cy="461772"/>
           </a:xfrm>
           <a:prstGeom prst="rect">
             <a:avLst/>
@@ -4417,8 +4417,8 @@
         </p:nvSpPr>
         <p:spPr>
           <a:xfrm>
-            <a:off x="2926080" y="3355848"/>
-            <a:ext cx="3419856" cy="580644"/>
+            <a:off x="2926080" y="3063240"/>
+            <a:ext cx="3419856" cy="461772"/>
           </a:xfrm>
           <a:prstGeom prst="rect">
             <a:avLst/>
@@ -4446,7 +4446,7 @@
                 <a:ea typeface="Microsoft YaHei"/>
                 <a:cs typeface="Microsoft YaHei"/>
               </a:rPr>
-              <a:t>前处理、自回归、后处理。Executor 负责跨节点下发。</a:t>
+              <a:t>自回归执行。Executor 负责跨节点下发。</a:t>
             </a:r>
           </a:p>
         </p:txBody>
@@ -4459,8 +4459,8 @@
         </p:nvSpPr>
         <p:spPr>
           <a:xfrm>
-            <a:off x="1207008" y="3991356"/>
-            <a:ext cx="1627632" cy="580644"/>
+            <a:off x="1207008" y="3579876"/>
+            <a:ext cx="1627632" cy="461772"/>
           </a:xfrm>
           <a:prstGeom prst="rect">
             <a:avLst/>
@@ -4520,8 +4520,8 @@
         </p:nvSpPr>
         <p:spPr>
           <a:xfrm>
-            <a:off x="2834640" y="3991356"/>
-            <a:ext cx="3547872" cy="580644"/>
+            <a:off x="2834640" y="3579876"/>
+            <a:ext cx="3547872" cy="461772"/>
           </a:xfrm>
           <a:prstGeom prst="rect">
             <a:avLst/>
@@ -4563,8 +4563,8 @@
         </p:nvSpPr>
         <p:spPr>
           <a:xfrm>
-            <a:off x="2926080" y="3991356"/>
-            <a:ext cx="3419856" cy="580644"/>
+            <a:off x="2926080" y="3579876"/>
+            <a:ext cx="3419856" cy="461772"/>
           </a:xfrm>
           <a:prstGeom prst="rect">
             <a:avLst/>
@@ -4592,7 +4592,7 @@
                 <a:ea typeface="Microsoft YaHei"/>
                 <a:cs typeface="Microsoft YaHei"/>
               </a:rPr>
-              <a:t>ATB 模型与图执行。后端为 ACLGraph 和 ATBGraph。</a:t>
+              <a:t>ACLGraph 与 ATBGraph。</a:t>
             </a:r>
           </a:p>
         </p:txBody>
@@ -4605,8 +4605,8 @@
         </p:nvSpPr>
         <p:spPr>
           <a:xfrm>
-            <a:off x="6565392" y="1700784"/>
-            <a:ext cx="5321808" cy="2944368"/>
+            <a:off x="6565392" y="1645920"/>
+            <a:ext cx="5321808" cy="2468880"/>
           </a:xfrm>
           <a:prstGeom prst="rect">
             <a:avLst/>
@@ -4650,7 +4650,7 @@
         </p:nvSpPr>
         <p:spPr>
           <a:xfrm>
-            <a:off x="6565392" y="1700784"/>
+            <a:off x="6565392" y="1645920"/>
             <a:ext cx="5321808" cy="310896"/>
           </a:xfrm>
           <a:prstGeom prst="rect">
@@ -4711,8 +4711,8 @@
         </p:nvSpPr>
         <p:spPr>
           <a:xfrm>
-            <a:off x="6638544" y="2084832"/>
-            <a:ext cx="1627632" cy="580644"/>
+            <a:off x="6638544" y="2029968"/>
+            <a:ext cx="1627632" cy="461772"/>
           </a:xfrm>
           <a:prstGeom prst="rect">
             <a:avLst/>
@@ -4772,8 +4772,8 @@
         </p:nvSpPr>
         <p:spPr>
           <a:xfrm>
-            <a:off x="8266176" y="2084832"/>
-            <a:ext cx="3547872" cy="580644"/>
+            <a:off x="8266176" y="2029968"/>
+            <a:ext cx="3547872" cy="461772"/>
           </a:xfrm>
           <a:prstGeom prst="rect">
             <a:avLst/>
@@ -4815,8 +4815,8 @@
         </p:nvSpPr>
         <p:spPr>
           <a:xfrm>
-            <a:off x="8357616" y="2084832"/>
-            <a:ext cx="3419856" cy="580644"/>
+            <a:off x="8357616" y="2029968"/>
+            <a:ext cx="3419856" cy="461772"/>
           </a:xfrm>
           <a:prstGeom prst="rect">
             <a:avLst/>
@@ -4844,7 +4844,7 @@
                 <a:ea typeface="Microsoft YaHei"/>
                 <a:cs typeface="Microsoft YaHei"/>
               </a:rPr>
-              <a:t>数据面入口。路由、限流、实例隔离。</a:t>
+              <a:t>路由、限流、实例隔离。</a:t>
             </a:r>
           </a:p>
         </p:txBody>
@@ -4857,8 +4857,8 @@
         </p:nvSpPr>
         <p:spPr>
           <a:xfrm>
-            <a:off x="6638544" y="2720340"/>
-            <a:ext cx="1627632" cy="580644"/>
+            <a:off x="6638544" y="2546604"/>
+            <a:ext cx="1627632" cy="461772"/>
           </a:xfrm>
           <a:prstGeom prst="rect">
             <a:avLst/>
@@ -4918,8 +4918,8 @@
         </p:nvSpPr>
         <p:spPr>
           <a:xfrm>
-            <a:off x="8266176" y="2720340"/>
-            <a:ext cx="3547872" cy="580644"/>
+            <a:off x="8266176" y="2546604"/>
+            <a:ext cx="3547872" cy="461772"/>
           </a:xfrm>
           <a:prstGeom prst="rect">
             <a:avLst/>
@@ -4961,8 +4961,8 @@
         </p:nvSpPr>
         <p:spPr>
           <a:xfrm>
-            <a:off x="8357616" y="2720340"/>
-            <a:ext cx="3419856" cy="580644"/>
+            <a:off x="8357616" y="2546604"/>
+            <a:ext cx="3419856" cy="461772"/>
           </a:xfrm>
           <a:prstGeom prst="rect">
             <a:avLst/>
@@ -4990,7 +4990,7 @@
                 <a:ea typeface="Microsoft YaHei"/>
                 <a:cs typeface="Microsoft YaHei"/>
               </a:rPr>
-              <a:t>Controller 管 P/D 身份和故障。NodeManager 拉起节点并上报心跳。</a:t>
+              <a:t>Controller 与 NodeManager。</a:t>
             </a:r>
           </a:p>
         </p:txBody>
@@ -5003,8 +5003,8 @@
         </p:nvSpPr>
         <p:spPr>
           <a:xfrm>
-            <a:off x="6638544" y="3355848"/>
-            <a:ext cx="1627632" cy="580644"/>
+            <a:off x="6638544" y="3063240"/>
+            <a:ext cx="1627632" cy="461772"/>
           </a:xfrm>
           <a:prstGeom prst="rect">
             <a:avLst/>
@@ -5064,8 +5064,8 @@
         </p:nvSpPr>
         <p:spPr>
           <a:xfrm>
-            <a:off x="8266176" y="3355848"/>
-            <a:ext cx="3547872" cy="580644"/>
+            <a:off x="8266176" y="3063240"/>
+            <a:ext cx="3547872" cy="461772"/>
           </a:xfrm>
           <a:prstGeom prst="rect">
             <a:avLst/>
@@ -5107,8 +5107,8 @@
         </p:nvSpPr>
         <p:spPr>
           <a:xfrm>
-            <a:off x="8357616" y="3355848"/>
-            <a:ext cx="3419856" cy="580644"/>
+            <a:off x="8357616" y="3063240"/>
+            <a:ext cx="3419856" cy="461772"/>
           </a:xfrm>
           <a:prstGeom prst="rect">
             <a:avLst/>
@@ -5136,7 +5136,7 @@
                 <a:ea typeface="Microsoft YaHei"/>
                 <a:cs typeface="Microsoft YaHei"/>
               </a:rPr>
-              <a:t>节点入口。北向接 Coordinator 和 Controller。</a:t>
+              <a:t>北向接 Coordinator 和 Controller。</a:t>
             </a:r>
           </a:p>
         </p:txBody>
@@ -5149,8 +5149,8 @@
         </p:nvSpPr>
         <p:spPr>
           <a:xfrm>
-            <a:off x="6638544" y="3991356"/>
-            <a:ext cx="1627632" cy="580644"/>
+            <a:off x="6638544" y="3579876"/>
+            <a:ext cx="1627632" cy="461772"/>
           </a:xfrm>
           <a:prstGeom prst="rect">
             <a:avLst/>
@@ -5210,8 +5210,8 @@
         </p:nvSpPr>
         <p:spPr>
           <a:xfrm>
-            <a:off x="8266176" y="3991356"/>
-            <a:ext cx="3547872" cy="580644"/>
+            <a:off x="8266176" y="3579876"/>
+            <a:ext cx="3547872" cy="461772"/>
           </a:xfrm>
           <a:prstGeom prst="rect">
             <a:avLst/>
@@ -5253,8 +5253,8 @@
         </p:nvSpPr>
         <p:spPr>
           <a:xfrm>
-            <a:off x="8357616" y="3991356"/>
-            <a:ext cx="3419856" cy="580644"/>
+            <a:off x="8357616" y="3579876"/>
+            <a:ext cx="3419856" cy="461772"/>
           </a:xfrm>
           <a:prstGeom prst="rect">
             <a:avLst/>
@@ -5282,7 +5282,7 @@
                 <a:ea typeface="Microsoft YaHei"/>
                 <a:cs typeface="Microsoft YaHei"/>
               </a:rPr>
-              <a:t>当前版本唯一南向引擎。前向和实例内组批在这里。</a:t>
+              <a:t>当前唯一南向。前向和实例内组批。</a:t>
             </a:r>
           </a:p>
         </p:txBody>
@@ -5295,8 +5295,431 @@
         </p:nvSpPr>
         <p:spPr>
           <a:xfrm>
-            <a:off x="256032" y="4754880"/>
-            <a:ext cx="841248" cy="512064"/>
+            <a:off x="256032" y="4206240"/>
+            <a:ext cx="841248" cy="658368"/>
+          </a:xfrm>
+          <a:prstGeom prst="rect">
+            <a:avLst/>
+          </a:prstGeom>
+          <a:noFill/>
+        </p:spPr>
+        <p:txBody>
+          <a:bodyPr wrap="square" lIns="0" rIns="0" tIns="0" bIns="0" anchor="ctr"/>
+          <a:lstStyle/>
+          <a:p>
+            <a:pPr algn="l">
+              <a:spcBef>
+                <a:spcPts val="0"/>
+              </a:spcBef>
+              <a:spcAft>
+                <a:spcPts val="0"/>
+              </a:spcAft>
+            </a:pPr>
+            <a:r>
+              <a:rPr sz="1300" b="1">
+                <a:solidFill>
+                  <a:srgbClr val="0E7A76"/>
+                </a:solidFill>
+                <a:latin typeface="Microsoft YaHei"/>
+                <a:ea typeface="Microsoft YaHei"/>
+                <a:cs typeface="Microsoft YaHei"/>
+              </a:rPr>
+              <a:t>KV</a:t>
+            </a:r>
+          </a:p>
+        </p:txBody>
+      </p:sp>
+      <p:sp>
+        <p:nvSpPr>
+          <p:cNvPr id="40" name="Rectangle 39"/>
+          <p:cNvSpPr/>
+          <p:nvPr/>
+        </p:nvSpPr>
+        <p:spPr>
+          <a:xfrm>
+            <a:off x="1133856" y="4206240"/>
+            <a:ext cx="3535680" cy="658368"/>
+          </a:xfrm>
+          <a:prstGeom prst="rect">
+            <a:avLst/>
+          </a:prstGeom>
+          <a:solidFill>
+            <a:srgbClr val="0E7A76"/>
+          </a:solidFill>
+          <a:ln>
+            <a:noFill/>
+          </a:ln>
+        </p:spPr>
+        <p:style>
+          <a:lnRef idx="1">
+            <a:schemeClr val="accent1"/>
+          </a:lnRef>
+          <a:fillRef idx="3">
+            <a:schemeClr val="accent1"/>
+          </a:fillRef>
+          <a:effectRef idx="2">
+            <a:schemeClr val="accent1"/>
+          </a:effectRef>
+          <a:fontRef idx="minor">
+            <a:schemeClr val="lt1"/>
+          </a:fontRef>
+        </p:style>
+        <p:txBody>
+          <a:bodyPr rtlCol="0" anchor="ctr"/>
+          <a:lstStyle/>
+          <a:p>
+            <a:pPr algn="ctr"/>
+          </a:p>
+        </p:txBody>
+      </p:sp>
+      <p:sp>
+        <p:nvSpPr>
+          <p:cNvPr id="41" name="TextBox 40"/>
+          <p:cNvSpPr txBox="1"/>
+          <p:nvPr/>
+        </p:nvSpPr>
+        <p:spPr>
+          <a:xfrm>
+            <a:off x="1225296" y="4261103"/>
+            <a:ext cx="3352800" cy="237744"/>
+          </a:xfrm>
+          <a:prstGeom prst="rect">
+            <a:avLst/>
+          </a:prstGeom>
+          <a:noFill/>
+        </p:spPr>
+        <p:txBody>
+          <a:bodyPr wrap="square" lIns="0" rIns="0" tIns="0" bIns="0" anchor="ctr"/>
+          <a:lstStyle/>
+          <a:p>
+            <a:pPr algn="l">
+              <a:spcBef>
+                <a:spcPts val="0"/>
+              </a:spcBef>
+              <a:spcAft>
+                <a:spcPts val="0"/>
+              </a:spcAft>
+            </a:pPr>
+            <a:r>
+              <a:rPr sz="1400" b="1">
+                <a:solidFill>
+                  <a:srgbClr val="FFFFFF"/>
+                </a:solidFill>
+                <a:latin typeface="Microsoft YaHei"/>
+                <a:ea typeface="Microsoft YaHei"/>
+                <a:cs typeface="Microsoft YaHei"/>
+              </a:rPr>
+              <a:t>实例内 KV</a:t>
+            </a:r>
+          </a:p>
+        </p:txBody>
+      </p:sp>
+      <p:sp>
+        <p:nvSpPr>
+          <p:cNvPr id="42" name="TextBox 41"/>
+          <p:cNvSpPr txBox="1"/>
+          <p:nvPr/>
+        </p:nvSpPr>
+        <p:spPr>
+          <a:xfrm>
+            <a:off x="1225296" y="4498848"/>
+            <a:ext cx="3352800" cy="310896"/>
+          </a:xfrm>
+          <a:prstGeom prst="rect">
+            <a:avLst/>
+          </a:prstGeom>
+          <a:noFill/>
+        </p:spPr>
+        <p:txBody>
+          <a:bodyPr wrap="square" lIns="0" rIns="0" tIns="0" bIns="0" anchor="t"/>
+          <a:lstStyle/>
+          <a:p>
+            <a:pPr algn="l">
+              <a:spcBef>
+                <a:spcPts val="0"/>
+              </a:spcBef>
+              <a:spcAft>
+                <a:spcPts val="0"/>
+              </a:spcAft>
+            </a:pPr>
+            <a:r>
+              <a:rPr sz="1200" b="0">
+                <a:solidFill>
+                  <a:srgbClr val="FFFFFF"/>
+                </a:solidFill>
+                <a:latin typeface="Microsoft YaHei"/>
+                <a:ea typeface="Microsoft YaHei"/>
+                <a:cs typeface="Microsoft YaHei"/>
+              </a:rPr>
+              <a:t>Block Manager，以及 vLLM 的本卡池</a:t>
+            </a:r>
+          </a:p>
+        </p:txBody>
+      </p:sp>
+      <p:sp>
+        <p:nvSpPr>
+          <p:cNvPr id="43" name="Rectangle 42"/>
+          <p:cNvSpPr/>
+          <p:nvPr/>
+        </p:nvSpPr>
+        <p:spPr>
+          <a:xfrm>
+            <a:off x="4742688" y="4206240"/>
+            <a:ext cx="3535680" cy="658368"/>
+          </a:xfrm>
+          <a:prstGeom prst="rect">
+            <a:avLst/>
+          </a:prstGeom>
+          <a:solidFill>
+            <a:srgbClr val="145A96"/>
+          </a:solidFill>
+          <a:ln>
+            <a:noFill/>
+          </a:ln>
+        </p:spPr>
+        <p:style>
+          <a:lnRef idx="1">
+            <a:schemeClr val="accent1"/>
+          </a:lnRef>
+          <a:fillRef idx="3">
+            <a:schemeClr val="accent1"/>
+          </a:fillRef>
+          <a:effectRef idx="2">
+            <a:schemeClr val="accent1"/>
+          </a:effectRef>
+          <a:fontRef idx="minor">
+            <a:schemeClr val="lt1"/>
+          </a:fontRef>
+        </p:style>
+        <p:txBody>
+          <a:bodyPr rtlCol="0" anchor="ctr"/>
+          <a:lstStyle/>
+          <a:p>
+            <a:pPr algn="ctr"/>
+          </a:p>
+        </p:txBody>
+      </p:sp>
+      <p:sp>
+        <p:nvSpPr>
+          <p:cNvPr id="44" name="TextBox 43"/>
+          <p:cNvSpPr txBox="1"/>
+          <p:nvPr/>
+        </p:nvSpPr>
+        <p:spPr>
+          <a:xfrm>
+            <a:off x="4834128" y="4261103"/>
+            <a:ext cx="3352800" cy="237744"/>
+          </a:xfrm>
+          <a:prstGeom prst="rect">
+            <a:avLst/>
+          </a:prstGeom>
+          <a:noFill/>
+        </p:spPr>
+        <p:txBody>
+          <a:bodyPr wrap="square" lIns="0" rIns="0" tIns="0" bIns="0" anchor="ctr"/>
+          <a:lstStyle/>
+          <a:p>
+            <a:pPr algn="l">
+              <a:spcBef>
+                <a:spcPts val="0"/>
+              </a:spcBef>
+              <a:spcAft>
+                <a:spcPts val="0"/>
+              </a:spcAft>
+            </a:pPr>
+            <a:r>
+              <a:rPr sz="1400" b="1">
+                <a:solidFill>
+                  <a:srgbClr val="FFFFFF"/>
+                </a:solidFill>
+                <a:latin typeface="Microsoft YaHei"/>
+                <a:ea typeface="Microsoft YaHei"/>
+                <a:cs typeface="Microsoft YaHei"/>
+              </a:rPr>
+              <a:t>跨实例搬运</a:t>
+            </a:r>
+          </a:p>
+        </p:txBody>
+      </p:sp>
+      <p:sp>
+        <p:nvSpPr>
+          <p:cNvPr id="45" name="TextBox 44"/>
+          <p:cNvSpPr txBox="1"/>
+          <p:nvPr/>
+        </p:nvSpPr>
+        <p:spPr>
+          <a:xfrm>
+            <a:off x="4834128" y="4498848"/>
+            <a:ext cx="3352800" cy="310896"/>
+          </a:xfrm>
+          <a:prstGeom prst="rect">
+            <a:avLst/>
+          </a:prstGeom>
+          <a:noFill/>
+        </p:spPr>
+        <p:txBody>
+          <a:bodyPr wrap="square" lIns="0" rIns="0" tIns="0" bIns="0" anchor="t"/>
+          <a:lstStyle/>
+          <a:p>
+            <a:pPr algn="l">
+              <a:spcBef>
+                <a:spcPts val="0"/>
+              </a:spcBef>
+              <a:spcAft>
+                <a:spcPts val="0"/>
+              </a:spcAft>
+            </a:pPr>
+            <a:r>
+              <a:rPr sz="1200" b="0">
+                <a:solidFill>
+                  <a:srgbClr val="FFFFFF"/>
+                </a:solidFill>
+                <a:latin typeface="Microsoft YaHei"/>
+                <a:ea typeface="Microsoft YaHei"/>
+                <a:cs typeface="Microsoft YaHei"/>
+              </a:rPr>
+              <a:t>kv connector 与 MooncakeConnector</a:t>
+            </a:r>
+          </a:p>
+        </p:txBody>
+      </p:sp>
+      <p:sp>
+        <p:nvSpPr>
+          <p:cNvPr id="46" name="Rectangle 45"/>
+          <p:cNvSpPr/>
+          <p:nvPr/>
+        </p:nvSpPr>
+        <p:spPr>
+          <a:xfrm>
+            <a:off x="8351520" y="4206240"/>
+            <a:ext cx="3535680" cy="658368"/>
+          </a:xfrm>
+          <a:prstGeom prst="rect">
+            <a:avLst/>
+          </a:prstGeom>
+          <a:solidFill>
+            <a:srgbClr val="7A541C"/>
+          </a:solidFill>
+          <a:ln>
+            <a:noFill/>
+          </a:ln>
+        </p:spPr>
+        <p:style>
+          <a:lnRef idx="1">
+            <a:schemeClr val="accent1"/>
+          </a:lnRef>
+          <a:fillRef idx="3">
+            <a:schemeClr val="accent1"/>
+          </a:fillRef>
+          <a:effectRef idx="2">
+            <a:schemeClr val="accent1"/>
+          </a:effectRef>
+          <a:fontRef idx="minor">
+            <a:schemeClr val="lt1"/>
+          </a:fontRef>
+        </p:style>
+        <p:txBody>
+          <a:bodyPr rtlCol="0" anchor="ctr"/>
+          <a:lstStyle/>
+          <a:p>
+            <a:pPr algn="ctr"/>
+          </a:p>
+        </p:txBody>
+      </p:sp>
+      <p:sp>
+        <p:nvSpPr>
+          <p:cNvPr id="47" name="TextBox 46"/>
+          <p:cNvSpPr txBox="1"/>
+          <p:nvPr/>
+        </p:nvSpPr>
+        <p:spPr>
+          <a:xfrm>
+            <a:off x="8442960" y="4261103"/>
+            <a:ext cx="3352800" cy="237744"/>
+          </a:xfrm>
+          <a:prstGeom prst="rect">
+            <a:avLst/>
+          </a:prstGeom>
+          <a:noFill/>
+        </p:spPr>
+        <p:txBody>
+          <a:bodyPr wrap="square" lIns="0" rIns="0" tIns="0" bIns="0" anchor="ctr"/>
+          <a:lstStyle/>
+          <a:p>
+            <a:pPr algn="l">
+              <a:spcBef>
+                <a:spcPts val="0"/>
+              </a:spcBef>
+              <a:spcAft>
+                <a:spcPts val="0"/>
+              </a:spcAft>
+            </a:pPr>
+            <a:r>
+              <a:rPr sz="1400" b="1">
+                <a:solidFill>
+                  <a:srgbClr val="FFFFFF"/>
+                </a:solidFill>
+                <a:latin typeface="Microsoft YaHei"/>
+                <a:ea typeface="Microsoft YaHei"/>
+                <a:cs typeface="Microsoft YaHei"/>
+              </a:rPr>
+              <a:t>Mooncake</a:t>
+            </a:r>
+          </a:p>
+        </p:txBody>
+      </p:sp>
+      <p:sp>
+        <p:nvSpPr>
+          <p:cNvPr id="48" name="TextBox 47"/>
+          <p:cNvSpPr txBox="1"/>
+          <p:nvPr/>
+        </p:nvSpPr>
+        <p:spPr>
+          <a:xfrm>
+            <a:off x="8442960" y="4498848"/>
+            <a:ext cx="3352800" cy="310896"/>
+          </a:xfrm>
+          <a:prstGeom prst="rect">
+            <a:avLst/>
+          </a:prstGeom>
+          <a:noFill/>
+        </p:spPr>
+        <p:txBody>
+          <a:bodyPr wrap="square" lIns="0" rIns="0" tIns="0" bIns="0" anchor="t"/>
+          <a:lstStyle/>
+          <a:p>
+            <a:pPr algn="l">
+              <a:spcBef>
+                <a:spcPts val="0"/>
+              </a:spcBef>
+              <a:spcAft>
+                <a:spcPts val="0"/>
+              </a:spcAft>
+            </a:pPr>
+            <a:r>
+              <a:rPr sz="1200" b="0">
+                <a:solidFill>
+                  <a:srgbClr val="FFFFFF"/>
+                </a:solidFill>
+                <a:latin typeface="Microsoft YaHei"/>
+                <a:ea typeface="Microsoft YaHei"/>
+                <a:cs typeface="Microsoft YaHei"/>
+              </a:rPr>
+              <a:t>Conductor 管位置，Store 做共享池</a:t>
+            </a:r>
+          </a:p>
+        </p:txBody>
+      </p:sp>
+      <p:sp>
+        <p:nvSpPr>
+          <p:cNvPr id="49" name="TextBox 48"/>
+          <p:cNvSpPr txBox="1"/>
+          <p:nvPr/>
+        </p:nvSpPr>
+        <p:spPr>
+          <a:xfrm>
+            <a:off x="256032" y="4956048"/>
+            <a:ext cx="841248" cy="384048"/>
           </a:xfrm>
           <a:prstGeom prst="rect">
             <a:avLst/>
@@ -5331,14 +5754,14 @@
       </p:sp>
       <p:sp>
         <p:nvSpPr>
-          <p:cNvPr id="40" name="Rectangle 39"/>
+          <p:cNvPr id="50" name="Rectangle 49"/>
           <p:cNvSpPr/>
           <p:nvPr/>
         </p:nvSpPr>
         <p:spPr>
           <a:xfrm>
-            <a:off x="1133856" y="4754880"/>
-            <a:ext cx="1554480" cy="512064"/>
+            <a:off x="1133856" y="4956048"/>
+            <a:ext cx="1554480" cy="384048"/>
           </a:xfrm>
           <a:prstGeom prst="rect">
             <a:avLst/>
@@ -5392,14 +5815,14 @@
       </p:sp>
       <p:sp>
         <p:nvSpPr>
-          <p:cNvPr id="41" name="Rectangle 40"/>
+          <p:cNvPr id="51" name="Rectangle 50"/>
           <p:cNvSpPr/>
           <p:nvPr/>
         </p:nvSpPr>
         <p:spPr>
           <a:xfrm>
-            <a:off x="2688336" y="4754880"/>
-            <a:ext cx="9198864" cy="512064"/>
+            <a:off x="2688336" y="4956048"/>
+            <a:ext cx="9198864" cy="384048"/>
           </a:xfrm>
           <a:prstGeom prst="rect">
             <a:avLst/>
@@ -5435,14 +5858,14 @@
       </p:sp>
       <p:sp>
         <p:nvSpPr>
-          <p:cNvPr id="42" name="TextBox 41"/>
+          <p:cNvPr id="52" name="TextBox 51"/>
           <p:cNvSpPr txBox="1"/>
           <p:nvPr/>
         </p:nvSpPr>
         <p:spPr>
           <a:xfrm>
-            <a:off x="2798064" y="4754880"/>
-            <a:ext cx="9015984" cy="512064"/>
+            <a:off x="2798064" y="4956048"/>
+            <a:ext cx="9015984" cy="384048"/>
           </a:xfrm>
           <a:prstGeom prst="rect">
             <a:avLst/>
@@ -5477,14 +5900,14 @@
       </p:sp>
       <p:sp>
         <p:nvSpPr>
-          <p:cNvPr id="43" name="TextBox 42"/>
+          <p:cNvPr id="53" name="TextBox 52"/>
           <p:cNvSpPr txBox="1"/>
           <p:nvPr/>
         </p:nvSpPr>
         <p:spPr>
           <a:xfrm>
-            <a:off x="256032" y="5321808"/>
-            <a:ext cx="841248" cy="384048"/>
+            <a:off x="256032" y="5394960"/>
+            <a:ext cx="841248" cy="310896"/>
           </a:xfrm>
           <a:prstGeom prst="rect">
             <a:avLst/>
@@ -5519,14 +5942,14 @@
       </p:sp>
       <p:sp>
         <p:nvSpPr>
-          <p:cNvPr id="44" name="Rectangle 43"/>
+          <p:cNvPr id="54" name="Rectangle 53"/>
           <p:cNvSpPr/>
           <p:nvPr/>
         </p:nvSpPr>
         <p:spPr>
           <a:xfrm>
-            <a:off x="1133856" y="5321808"/>
-            <a:ext cx="1554480" cy="384048"/>
+            <a:off x="1133856" y="5394960"/>
+            <a:ext cx="1554480" cy="310896"/>
           </a:xfrm>
           <a:prstGeom prst="rect">
             <a:avLst/>
@@ -5580,14 +6003,14 @@
       </p:sp>
       <p:sp>
         <p:nvSpPr>
-          <p:cNvPr id="45" name="Rectangle 44"/>
+          <p:cNvPr id="55" name="Rectangle 54"/>
           <p:cNvSpPr/>
           <p:nvPr/>
         </p:nvSpPr>
         <p:spPr>
           <a:xfrm>
-            <a:off x="2688336" y="5321808"/>
-            <a:ext cx="9198864" cy="384048"/>
+            <a:off x="2688336" y="5394960"/>
+            <a:ext cx="9198864" cy="310896"/>
           </a:xfrm>
           <a:prstGeom prst="rect">
             <a:avLst/>
@@ -5623,14 +6046,14 @@
       </p:sp>
       <p:sp>
         <p:nvSpPr>
-          <p:cNvPr id="46" name="TextBox 45"/>
+          <p:cNvPr id="56" name="TextBox 55"/>
           <p:cNvSpPr txBox="1"/>
           <p:nvPr/>
         </p:nvSpPr>
         <p:spPr>
           <a:xfrm>
-            <a:off x="2798064" y="5321808"/>
-            <a:ext cx="9015984" cy="384048"/>
+            <a:off x="2798064" y="5394960"/>
+            <a:ext cx="9015984" cy="310896"/>
           </a:xfrm>
           <a:prstGeom prst="rect">
             <a:avLst/>
@@ -5665,14 +6088,14 @@
       </p:sp>
       <p:sp>
         <p:nvSpPr>
-          <p:cNvPr id="47" name="TextBox 46"/>
+          <p:cNvPr id="57" name="TextBox 56"/>
           <p:cNvSpPr txBox="1"/>
           <p:nvPr/>
         </p:nvSpPr>
         <p:spPr>
           <a:xfrm>
             <a:off x="256032" y="5760720"/>
-            <a:ext cx="841248" cy="384048"/>
+            <a:ext cx="841248" cy="310896"/>
           </a:xfrm>
           <a:prstGeom prst="rect">
             <a:avLst/>
@@ -5707,14 +6130,14 @@
       </p:sp>
       <p:sp>
         <p:nvSpPr>
-          <p:cNvPr id="48" name="Rectangle 47"/>
+          <p:cNvPr id="58" name="Rectangle 57"/>
           <p:cNvSpPr/>
           <p:nvPr/>
         </p:nvSpPr>
         <p:spPr>
           <a:xfrm>
             <a:off x="1133856" y="5760720"/>
-            <a:ext cx="1554480" cy="384048"/>
+            <a:ext cx="1554480" cy="310896"/>
           </a:xfrm>
           <a:prstGeom prst="rect">
             <a:avLst/>
@@ -5768,14 +6191,14 @@
       </p:sp>
       <p:sp>
         <p:nvSpPr>
-          <p:cNvPr id="49" name="Rectangle 48"/>
+          <p:cNvPr id="59" name="Rectangle 58"/>
           <p:cNvSpPr/>
           <p:nvPr/>
         </p:nvSpPr>
         <p:spPr>
           <a:xfrm>
             <a:off x="2688336" y="5760720"/>
-            <a:ext cx="9198864" cy="384048"/>
+            <a:ext cx="9198864" cy="310896"/>
           </a:xfrm>
           <a:prstGeom prst="rect">
             <a:avLst/>
@@ -5811,14 +6234,14 @@
       </p:sp>
       <p:sp>
         <p:nvSpPr>
-          <p:cNvPr id="50" name="TextBox 49"/>
+          <p:cNvPr id="60" name="TextBox 59"/>
           <p:cNvSpPr txBox="1"/>
           <p:nvPr/>
         </p:nvSpPr>
         <p:spPr>
           <a:xfrm>
             <a:off x="2798064" y="5760720"/>
-            <a:ext cx="9015984" cy="384048"/>
+            <a:ext cx="9015984" cy="310896"/>
           </a:xfrm>
           <a:prstGeom prst="rect">
             <a:avLst/>
@@ -5853,14 +6276,14 @@
       </p:sp>
       <p:sp>
         <p:nvSpPr>
-          <p:cNvPr id="51" name="TextBox 50"/>
+          <p:cNvPr id="61" name="TextBox 60"/>
           <p:cNvSpPr txBox="1"/>
           <p:nvPr/>
         </p:nvSpPr>
         <p:spPr>
           <a:xfrm>
-            <a:off x="292608" y="6199632"/>
-            <a:ext cx="11612880" cy="512064"/>
+            <a:off x="292608" y="6126480"/>
+            <a:ext cx="11612880" cy="585216"/>
           </a:xfrm>
           <a:prstGeom prst="rect">
             <a:avLst/>
@@ -5888,7 +6311,7 @@
                 <a:ea typeface="Microsoft YaHei"/>
                 <a:cs typeface="Microsoft YaHei"/>
               </a:rPr>
-              <a:t>两条路径互不为下层。Motor 不跑模型前向；实例内组批在 LLM Manager，或在 vLLM-Ascend。</a:t>
+              <a:t>Mooncake 不是调用链上的一层。Conductor 把 KV 位置交给 Coordinator 做亲和调度；Store 和 connector 挂在引擎侧。</a:t>
             </a:r>
           </a:p>
           <a:p>
@@ -5909,7 +6332,7 @@
                 <a:ea typeface="Microsoft YaHei"/>
                 <a:cs typeface="Microsoft YaHei"/>
               </a:rPr>
-              <a:t>EngineServer 的接口写了 vLLM、SGLang 和 MindIE，这一版只支持 vLLM。</a:t>
+              <a:t>池化还可选 MemCache。亲和调度与按层推入共享池是两套配置，不叠在同一次传输上。</a:t>
             </a:r>
           </a:p>
         </p:txBody>

</xml_diff>

<commit_message>
docs: add MemCache and the CANN communication libraries
Place MemCache, Mooncake, and YuanRong as KV pool backends, and show HCCL, HCOMM, HIXL, and SHMEM inside CANN.

Co-authored-by: 69515164-rgb <69515164-rgb@users.noreply.github.com>
</commit_message>
<xml_diff>
--- a/docs/ascend-infer-stack.pptx
+++ b/docs/ascend-infer-stack.pptx
@@ -502,7 +502,7 @@
           <a:lstStyle/>
           <a:p>
             <a:r>
-              <a:t>依据 MindIE 3.1 用户手册 Overview 与 MindIE Motor 3.1 架构说明。MindIE LLM 进入维护，官方建议新部署使用 MindIE Motor 加 vLLM-Ascend。MindIE LLM 自上而下为 Server、LLM Manager、Text Generator、Modeling。LLM Manager 内的 Engine 编排 Scheduler、Executor 和 Worker；Block Manager 管 KV 池。Executor 把调度结果下发给 Text Generator，覆盖跨节点、跨设备。Text Generator 含前处理、Generator、Sampler，并支持可插拔的并行解码。Modeling 提供 ATB Models；开发者架构说明同时支持 ACLGraph 和 ATBGraph。Motor：Coordinator 为数据面入口；Controller 与 NodeManager 为管控面；EngineServer 北向接二者，南向当前仅 vLLM。架构页写明南向接口包括 vLLM、SGLang 和 MindIE，当前版本只支持 vLLM。MindCluster 提供 Kubernetes、PD 分离 CRD 和 Operator，位于调用链外侧。CCAE 可选。CANN 组成沿用方案概述：AscendCL、GE、Runtime、算子库、HCCL、DVPP。推理运行包为 NNRT。KV：MindIE LLM 的 Block Manager 管 DP 内 KV，kv connector 对接池化后端，Mooncake 是其中一种 backend。Motor 的亲和调度依赖 Mooncake Conductor：P 实例用 ZMQ 发布 KV 事件，Coordinator 按位置调度。3.1 中文页写优先送到已缓存该 KV 的 D 实例；英文页写优先送到已有前缀 KV 的 P 实例。图上只写按位置调度。Motor 的 KV 池基于 vLLM-Ascend：MultiConnector 把 MooncakeConnector 与 AscendStoreConnector 组合。Mooncake Store 由 mooncake_master 管理；另一后端是 MemCache。Conductor 设计里还可接 YuanRong。共享池推入可以使用按层 connector。亲和调度文档建议此时不要再按层单独传输，由 Conductor 管全局位置。</a:t>
+              <a:t>依据 MindIE 3.1 用户手册 Overview 与 MindIE Motor 3.1 架构说明。MindIE LLM 进入维护，官方建议新部署使用 MindIE Motor 加 vLLM-Ascend。MindIE LLM 自上而下为 Server、LLM Manager、Text Generator、Modeling。LLM Manager 内的 Engine 编排 Scheduler、Executor 和 Worker；Block Manager 管 KV 池。Executor 把调度结果下发给 Text Generator，覆盖跨节点、跨设备。Text Generator 含前处理、Generator、Sampler，并支持可插拔的并行解码。Modeling 提供 ATB Models；开发者架构说明同时支持 ACLGraph 和 ATBGraph。Motor：Coordinator 为数据面入口；Controller 与 NodeManager 为管控面；EngineServer 北向接二者，南向当前仅 vLLM。架构页写明南向接口包括 vLLM、SGLang 和 MindIE，当前版本只支持 vLLM。MindCluster 提供 Kubernetes、PD 分离 CRD 和 Operator，位于调用链外侧。CCAE 可选。CANN 组成沿用方案概述：AscendCL、GE、Runtime、算子库、HCCL、DVPP。推理运行包为 NNRT。KV 池：Motor 3.1 默认后端是 MemCache，由 MetaService 管元数据、LocalService 管 DRAM；Mooncake 用 mooncake_master；还有 YuanRong。vLLM-Ascend 的按层池化目前只支持 MemCache。Mooncake Conductor 给 Coordinator 提供 KV 位置，用于亲和调度。通信库都在 CANN 内。HCCL 是集合通信库，服务张量并行和专家并行；HCOMM 是它的基础库，控制面管拓扑和资源，数据面管搬运和同步。HIXL 是单边通信库，LLM-DataDist 在这里做链路和 KV 的拉取、推送，支持 D2D、D2H、H2D。SHMEM 是对称内存库，给算子开发提供卡间单边访问。用户所说的 HCOM 对应文档名 HCOMM。</a:t>
             </a:r>
           </a:p>
         </p:txBody>
@@ -3685,8 +3685,8 @@
         </p:nvSpPr>
         <p:spPr>
           <a:xfrm>
-            <a:off x="256032" y="1133856"/>
-            <a:ext cx="841248" cy="438912"/>
+            <a:off x="256032" y="1115568"/>
+            <a:ext cx="841248" cy="329184"/>
           </a:xfrm>
           <a:prstGeom prst="rect">
             <a:avLst/>
@@ -3727,8 +3727,8 @@
         </p:nvSpPr>
         <p:spPr>
           <a:xfrm>
-            <a:off x="1133856" y="1133856"/>
-            <a:ext cx="1554480" cy="438912"/>
+            <a:off x="1133856" y="1115568"/>
+            <a:ext cx="1554480" cy="329184"/>
           </a:xfrm>
           <a:prstGeom prst="rect">
             <a:avLst/>
@@ -3788,8 +3788,8 @@
         </p:nvSpPr>
         <p:spPr>
           <a:xfrm>
-            <a:off x="2688336" y="1133856"/>
-            <a:ext cx="9198864" cy="438912"/>
+            <a:off x="2688336" y="1115568"/>
+            <a:ext cx="9198864" cy="329184"/>
           </a:xfrm>
           <a:prstGeom prst="rect">
             <a:avLst/>
@@ -3831,8 +3831,8 @@
         </p:nvSpPr>
         <p:spPr>
           <a:xfrm>
-            <a:off x="2798064" y="1133856"/>
-            <a:ext cx="9015984" cy="438912"/>
+            <a:off x="2798064" y="1115568"/>
+            <a:ext cx="9015984" cy="329184"/>
           </a:xfrm>
           <a:prstGeom prst="rect">
             <a:avLst/>
@@ -3860,7 +3860,7 @@
                 <a:ea typeface="Microsoft YaHei"/>
                 <a:cs typeface="Microsoft YaHei"/>
               </a:rPr>
-              <a:t>调用链外侧。承接两条路径的 Pod、PD 分离 CRD 和故障恢复。可选 CCAE 做算存网运维。</a:t>
+              <a:t>调用链外侧。Pod、PD 分离、故障恢复。可选 CCAE。</a:t>
             </a:r>
           </a:p>
         </p:txBody>
@@ -3873,8 +3873,8 @@
         </p:nvSpPr>
         <p:spPr>
           <a:xfrm>
-            <a:off x="256032" y="1645920"/>
-            <a:ext cx="841248" cy="2468880"/>
+            <a:off x="256032" y="1517904"/>
+            <a:ext cx="841248" cy="2267712"/>
           </a:xfrm>
           <a:prstGeom prst="rect">
             <a:avLst/>
@@ -3915,8 +3915,8 @@
         </p:nvSpPr>
         <p:spPr>
           <a:xfrm>
-            <a:off x="1133856" y="1645920"/>
-            <a:ext cx="5321808" cy="2468880"/>
+            <a:off x="1133856" y="1517904"/>
+            <a:ext cx="5321808" cy="2267712"/>
           </a:xfrm>
           <a:prstGeom prst="rect">
             <a:avLst/>
@@ -3960,7 +3960,7 @@
         </p:nvSpPr>
         <p:spPr>
           <a:xfrm>
-            <a:off x="1133856" y="1645920"/>
+            <a:off x="1133856" y="1517904"/>
             <a:ext cx="5321808" cy="310896"/>
           </a:xfrm>
           <a:prstGeom prst="rect">
@@ -4021,8 +4021,8 @@
         </p:nvSpPr>
         <p:spPr>
           <a:xfrm>
-            <a:off x="1207008" y="2029968"/>
-            <a:ext cx="1627632" cy="461772"/>
+            <a:off x="1207008" y="1901952"/>
+            <a:ext cx="1627632" cy="411480"/>
           </a:xfrm>
           <a:prstGeom prst="rect">
             <a:avLst/>
@@ -4082,8 +4082,8 @@
         </p:nvSpPr>
         <p:spPr>
           <a:xfrm>
-            <a:off x="2834640" y="2029968"/>
-            <a:ext cx="3547872" cy="461772"/>
+            <a:off x="2834640" y="1901952"/>
+            <a:ext cx="3547872" cy="411480"/>
           </a:xfrm>
           <a:prstGeom prst="rect">
             <a:avLst/>
@@ -4125,8 +4125,8 @@
         </p:nvSpPr>
         <p:spPr>
           <a:xfrm>
-            <a:off x="2926080" y="2029968"/>
-            <a:ext cx="3419856" cy="461772"/>
+            <a:off x="2926080" y="1901952"/>
+            <a:ext cx="3419856" cy="411480"/>
           </a:xfrm>
           <a:prstGeom prst="rect">
             <a:avLst/>
@@ -4167,8 +4167,8 @@
         </p:nvSpPr>
         <p:spPr>
           <a:xfrm>
-            <a:off x="1207008" y="2546604"/>
-            <a:ext cx="1627632" cy="461772"/>
+            <a:off x="1207008" y="2368296"/>
+            <a:ext cx="1627632" cy="411480"/>
           </a:xfrm>
           <a:prstGeom prst="rect">
             <a:avLst/>
@@ -4228,8 +4228,8 @@
         </p:nvSpPr>
         <p:spPr>
           <a:xfrm>
-            <a:off x="2834640" y="2546604"/>
-            <a:ext cx="3547872" cy="461772"/>
+            <a:off x="2834640" y="2368296"/>
+            <a:ext cx="3547872" cy="411480"/>
           </a:xfrm>
           <a:prstGeom prst="rect">
             <a:avLst/>
@@ -4271,8 +4271,8 @@
         </p:nvSpPr>
         <p:spPr>
           <a:xfrm>
-            <a:off x="2926080" y="2546604"/>
-            <a:ext cx="3419856" cy="461772"/>
+            <a:off x="2926080" y="2368296"/>
+            <a:ext cx="3419856" cy="411480"/>
           </a:xfrm>
           <a:prstGeom prst="rect">
             <a:avLst/>
@@ -4313,8 +4313,8 @@
         </p:nvSpPr>
         <p:spPr>
           <a:xfrm>
-            <a:off x="1207008" y="3063240"/>
-            <a:ext cx="1627632" cy="461772"/>
+            <a:off x="1207008" y="2834640"/>
+            <a:ext cx="1627632" cy="411480"/>
           </a:xfrm>
           <a:prstGeom prst="rect">
             <a:avLst/>
@@ -4374,8 +4374,8 @@
         </p:nvSpPr>
         <p:spPr>
           <a:xfrm>
-            <a:off x="2834640" y="3063240"/>
-            <a:ext cx="3547872" cy="461772"/>
+            <a:off x="2834640" y="2834640"/>
+            <a:ext cx="3547872" cy="411480"/>
           </a:xfrm>
           <a:prstGeom prst="rect">
             <a:avLst/>
@@ -4417,8 +4417,8 @@
         </p:nvSpPr>
         <p:spPr>
           <a:xfrm>
-            <a:off x="2926080" y="3063240"/>
-            <a:ext cx="3419856" cy="461772"/>
+            <a:off x="2926080" y="2834640"/>
+            <a:ext cx="3419856" cy="411480"/>
           </a:xfrm>
           <a:prstGeom prst="rect">
             <a:avLst/>
@@ -4459,8 +4459,8 @@
         </p:nvSpPr>
         <p:spPr>
           <a:xfrm>
-            <a:off x="1207008" y="3579876"/>
-            <a:ext cx="1627632" cy="461772"/>
+            <a:off x="1207008" y="3300984"/>
+            <a:ext cx="1627632" cy="411480"/>
           </a:xfrm>
           <a:prstGeom prst="rect">
             <a:avLst/>
@@ -4520,8 +4520,8 @@
         </p:nvSpPr>
         <p:spPr>
           <a:xfrm>
-            <a:off x="2834640" y="3579876"/>
-            <a:ext cx="3547872" cy="461772"/>
+            <a:off x="2834640" y="3300984"/>
+            <a:ext cx="3547872" cy="411480"/>
           </a:xfrm>
           <a:prstGeom prst="rect">
             <a:avLst/>
@@ -4563,8 +4563,8 @@
         </p:nvSpPr>
         <p:spPr>
           <a:xfrm>
-            <a:off x="2926080" y="3579876"/>
-            <a:ext cx="3419856" cy="461772"/>
+            <a:off x="2926080" y="3300984"/>
+            <a:ext cx="3419856" cy="411480"/>
           </a:xfrm>
           <a:prstGeom prst="rect">
             <a:avLst/>
@@ -4605,8 +4605,8 @@
         </p:nvSpPr>
         <p:spPr>
           <a:xfrm>
-            <a:off x="6565392" y="1645920"/>
-            <a:ext cx="5321808" cy="2468880"/>
+            <a:off x="6565392" y="1517904"/>
+            <a:ext cx="5321808" cy="2267712"/>
           </a:xfrm>
           <a:prstGeom prst="rect">
             <a:avLst/>
@@ -4650,7 +4650,7 @@
         </p:nvSpPr>
         <p:spPr>
           <a:xfrm>
-            <a:off x="6565392" y="1645920"/>
+            <a:off x="6565392" y="1517904"/>
             <a:ext cx="5321808" cy="310896"/>
           </a:xfrm>
           <a:prstGeom prst="rect">
@@ -4711,8 +4711,8 @@
         </p:nvSpPr>
         <p:spPr>
           <a:xfrm>
-            <a:off x="6638544" y="2029968"/>
-            <a:ext cx="1627632" cy="461772"/>
+            <a:off x="6638544" y="1901952"/>
+            <a:ext cx="1627632" cy="411480"/>
           </a:xfrm>
           <a:prstGeom prst="rect">
             <a:avLst/>
@@ -4772,8 +4772,8 @@
         </p:nvSpPr>
         <p:spPr>
           <a:xfrm>
-            <a:off x="8266176" y="2029968"/>
-            <a:ext cx="3547872" cy="461772"/>
+            <a:off x="8266176" y="1901952"/>
+            <a:ext cx="3547872" cy="411480"/>
           </a:xfrm>
           <a:prstGeom prst="rect">
             <a:avLst/>
@@ -4815,8 +4815,8 @@
         </p:nvSpPr>
         <p:spPr>
           <a:xfrm>
-            <a:off x="8357616" y="2029968"/>
-            <a:ext cx="3419856" cy="461772"/>
+            <a:off x="8357616" y="1901952"/>
+            <a:ext cx="3419856" cy="411480"/>
           </a:xfrm>
           <a:prstGeom prst="rect">
             <a:avLst/>
@@ -4857,8 +4857,8 @@
         </p:nvSpPr>
         <p:spPr>
           <a:xfrm>
-            <a:off x="6638544" y="2546604"/>
-            <a:ext cx="1627632" cy="461772"/>
+            <a:off x="6638544" y="2368296"/>
+            <a:ext cx="1627632" cy="411480"/>
           </a:xfrm>
           <a:prstGeom prst="rect">
             <a:avLst/>
@@ -4918,8 +4918,8 @@
         </p:nvSpPr>
         <p:spPr>
           <a:xfrm>
-            <a:off x="8266176" y="2546604"/>
-            <a:ext cx="3547872" cy="461772"/>
+            <a:off x="8266176" y="2368296"/>
+            <a:ext cx="3547872" cy="411480"/>
           </a:xfrm>
           <a:prstGeom prst="rect">
             <a:avLst/>
@@ -4961,8 +4961,8 @@
         </p:nvSpPr>
         <p:spPr>
           <a:xfrm>
-            <a:off x="8357616" y="2546604"/>
-            <a:ext cx="3419856" cy="461772"/>
+            <a:off x="8357616" y="2368296"/>
+            <a:ext cx="3419856" cy="411480"/>
           </a:xfrm>
           <a:prstGeom prst="rect">
             <a:avLst/>
@@ -5003,8 +5003,8 @@
         </p:nvSpPr>
         <p:spPr>
           <a:xfrm>
-            <a:off x="6638544" y="3063240"/>
-            <a:ext cx="1627632" cy="461772"/>
+            <a:off x="6638544" y="2834640"/>
+            <a:ext cx="1627632" cy="411480"/>
           </a:xfrm>
           <a:prstGeom prst="rect">
             <a:avLst/>
@@ -5064,8 +5064,8 @@
         </p:nvSpPr>
         <p:spPr>
           <a:xfrm>
-            <a:off x="8266176" y="3063240"/>
-            <a:ext cx="3547872" cy="461772"/>
+            <a:off x="8266176" y="2834640"/>
+            <a:ext cx="3547872" cy="411480"/>
           </a:xfrm>
           <a:prstGeom prst="rect">
             <a:avLst/>
@@ -5107,8 +5107,8 @@
         </p:nvSpPr>
         <p:spPr>
           <a:xfrm>
-            <a:off x="8357616" y="3063240"/>
-            <a:ext cx="3419856" cy="461772"/>
+            <a:off x="8357616" y="2834640"/>
+            <a:ext cx="3419856" cy="411480"/>
           </a:xfrm>
           <a:prstGeom prst="rect">
             <a:avLst/>
@@ -5149,8 +5149,8 @@
         </p:nvSpPr>
         <p:spPr>
           <a:xfrm>
-            <a:off x="6638544" y="3579876"/>
-            <a:ext cx="1627632" cy="461772"/>
+            <a:off x="6638544" y="3300984"/>
+            <a:ext cx="1627632" cy="411480"/>
           </a:xfrm>
           <a:prstGeom prst="rect">
             <a:avLst/>
@@ -5210,8 +5210,8 @@
         </p:nvSpPr>
         <p:spPr>
           <a:xfrm>
-            <a:off x="8266176" y="3579876"/>
-            <a:ext cx="3547872" cy="461772"/>
+            <a:off x="8266176" y="3300984"/>
+            <a:ext cx="3547872" cy="411480"/>
           </a:xfrm>
           <a:prstGeom prst="rect">
             <a:avLst/>
@@ -5253,8 +5253,8 @@
         </p:nvSpPr>
         <p:spPr>
           <a:xfrm>
-            <a:off x="8357616" y="3579876"/>
-            <a:ext cx="3419856" cy="461772"/>
+            <a:off x="8357616" y="3300984"/>
+            <a:ext cx="3419856" cy="411480"/>
           </a:xfrm>
           <a:prstGeom prst="rect">
             <a:avLst/>
@@ -5295,8 +5295,8 @@
         </p:nvSpPr>
         <p:spPr>
           <a:xfrm>
-            <a:off x="256032" y="4206240"/>
-            <a:ext cx="841248" cy="658368"/>
+            <a:off x="256032" y="3858768"/>
+            <a:ext cx="841248" cy="512064"/>
           </a:xfrm>
           <a:prstGeom prst="rect">
             <a:avLst/>
@@ -5316,15 +5316,15 @@
               </a:spcAft>
             </a:pPr>
             <a:r>
-              <a:rPr sz="1300" b="1">
+              <a:rPr sz="1200" b="1">
                 <a:solidFill>
-                  <a:srgbClr val="0E7A76"/>
+                  <a:srgbClr val="7A541C"/>
                 </a:solidFill>
                 <a:latin typeface="Microsoft YaHei"/>
                 <a:ea typeface="Microsoft YaHei"/>
                 <a:cs typeface="Microsoft YaHei"/>
               </a:rPr>
-              <a:t>KV</a:t>
+              <a:t>KV 池</a:t>
             </a:r>
           </a:p>
         </p:txBody>
@@ -5337,14 +5337,14 @@
         </p:nvSpPr>
         <p:spPr>
           <a:xfrm>
-            <a:off x="1133856" y="4206240"/>
-            <a:ext cx="3535680" cy="658368"/>
+            <a:off x="1133856" y="3858768"/>
+            <a:ext cx="3535680" cy="512064"/>
           </a:xfrm>
           <a:prstGeom prst="rect">
             <a:avLst/>
           </a:prstGeom>
           <a:solidFill>
-            <a:srgbClr val="0E7A76"/>
+            <a:srgbClr val="7A541C"/>
           </a:solidFill>
           <a:ln>
             <a:noFill/>
@@ -5380,8 +5380,8 @@
         </p:nvSpPr>
         <p:spPr>
           <a:xfrm>
-            <a:off x="1225296" y="4261103"/>
-            <a:ext cx="3352800" cy="237744"/>
+            <a:off x="1207008" y="3895344"/>
+            <a:ext cx="3389376" cy="219456"/>
           </a:xfrm>
           <a:prstGeom prst="rect">
             <a:avLst/>
@@ -5401,7 +5401,7 @@
               </a:spcAft>
             </a:pPr>
             <a:r>
-              <a:rPr sz="1400" b="1">
+              <a:rPr sz="1300" b="1">
                 <a:solidFill>
                   <a:srgbClr val="FFFFFF"/>
                 </a:solidFill>
@@ -5409,7 +5409,7 @@
                 <a:ea typeface="Microsoft YaHei"/>
                 <a:cs typeface="Microsoft YaHei"/>
               </a:rPr>
-              <a:t>实例内 KV</a:t>
+              <a:t>MemCache</a:t>
             </a:r>
           </a:p>
         </p:txBody>
@@ -5422,8 +5422,8 @@
         </p:nvSpPr>
         <p:spPr>
           <a:xfrm>
-            <a:off x="1225296" y="4498848"/>
-            <a:ext cx="3352800" cy="310896"/>
+            <a:off x="1207008" y="4114800"/>
+            <a:ext cx="3389376" cy="219456"/>
           </a:xfrm>
           <a:prstGeom prst="rect">
             <a:avLst/>
@@ -5443,7 +5443,7 @@
               </a:spcAft>
             </a:pPr>
             <a:r>
-              <a:rPr sz="1200" b="0">
+              <a:rPr sz="1100" b="0">
                 <a:solidFill>
                   <a:srgbClr val="FFFFFF"/>
                 </a:solidFill>
@@ -5451,7 +5451,7 @@
                 <a:ea typeface="Microsoft YaHei"/>
                 <a:cs typeface="Microsoft YaHei"/>
               </a:rPr>
-              <a:t>Block Manager，以及 vLLM 的本卡池</a:t>
+              <a:t>默认后端。元数据与 DRAM 池。</a:t>
             </a:r>
           </a:p>
         </p:txBody>
@@ -5464,135 +5464,8 @@
         </p:nvSpPr>
         <p:spPr>
           <a:xfrm>
-            <a:off x="4742688" y="4206240"/>
-            <a:ext cx="3535680" cy="658368"/>
-          </a:xfrm>
-          <a:prstGeom prst="rect">
-            <a:avLst/>
-          </a:prstGeom>
-          <a:solidFill>
-            <a:srgbClr val="145A96"/>
-          </a:solidFill>
-          <a:ln>
-            <a:noFill/>
-          </a:ln>
-        </p:spPr>
-        <p:style>
-          <a:lnRef idx="1">
-            <a:schemeClr val="accent1"/>
-          </a:lnRef>
-          <a:fillRef idx="3">
-            <a:schemeClr val="accent1"/>
-          </a:fillRef>
-          <a:effectRef idx="2">
-            <a:schemeClr val="accent1"/>
-          </a:effectRef>
-          <a:fontRef idx="minor">
-            <a:schemeClr val="lt1"/>
-          </a:fontRef>
-        </p:style>
-        <p:txBody>
-          <a:bodyPr rtlCol="0" anchor="ctr"/>
-          <a:lstStyle/>
-          <a:p>
-            <a:pPr algn="ctr"/>
-          </a:p>
-        </p:txBody>
-      </p:sp>
-      <p:sp>
-        <p:nvSpPr>
-          <p:cNvPr id="44" name="TextBox 43"/>
-          <p:cNvSpPr txBox="1"/>
-          <p:nvPr/>
-        </p:nvSpPr>
-        <p:spPr>
-          <a:xfrm>
-            <a:off x="4834128" y="4261103"/>
-            <a:ext cx="3352800" cy="237744"/>
-          </a:xfrm>
-          <a:prstGeom prst="rect">
-            <a:avLst/>
-          </a:prstGeom>
-          <a:noFill/>
-        </p:spPr>
-        <p:txBody>
-          <a:bodyPr wrap="square" lIns="0" rIns="0" tIns="0" bIns="0" anchor="ctr"/>
-          <a:lstStyle/>
-          <a:p>
-            <a:pPr algn="l">
-              <a:spcBef>
-                <a:spcPts val="0"/>
-              </a:spcBef>
-              <a:spcAft>
-                <a:spcPts val="0"/>
-              </a:spcAft>
-            </a:pPr>
-            <a:r>
-              <a:rPr sz="1400" b="1">
-                <a:solidFill>
-                  <a:srgbClr val="FFFFFF"/>
-                </a:solidFill>
-                <a:latin typeface="Microsoft YaHei"/>
-                <a:ea typeface="Microsoft YaHei"/>
-                <a:cs typeface="Microsoft YaHei"/>
-              </a:rPr>
-              <a:t>跨实例搬运</a:t>
-            </a:r>
-          </a:p>
-        </p:txBody>
-      </p:sp>
-      <p:sp>
-        <p:nvSpPr>
-          <p:cNvPr id="45" name="TextBox 44"/>
-          <p:cNvSpPr txBox="1"/>
-          <p:nvPr/>
-        </p:nvSpPr>
-        <p:spPr>
-          <a:xfrm>
-            <a:off x="4834128" y="4498848"/>
-            <a:ext cx="3352800" cy="310896"/>
-          </a:xfrm>
-          <a:prstGeom prst="rect">
-            <a:avLst/>
-          </a:prstGeom>
-          <a:noFill/>
-        </p:spPr>
-        <p:txBody>
-          <a:bodyPr wrap="square" lIns="0" rIns="0" tIns="0" bIns="0" anchor="t"/>
-          <a:lstStyle/>
-          <a:p>
-            <a:pPr algn="l">
-              <a:spcBef>
-                <a:spcPts val="0"/>
-              </a:spcBef>
-              <a:spcAft>
-                <a:spcPts val="0"/>
-              </a:spcAft>
-            </a:pPr>
-            <a:r>
-              <a:rPr sz="1200" b="0">
-                <a:solidFill>
-                  <a:srgbClr val="FFFFFF"/>
-                </a:solidFill>
-                <a:latin typeface="Microsoft YaHei"/>
-                <a:ea typeface="Microsoft YaHei"/>
-                <a:cs typeface="Microsoft YaHei"/>
-              </a:rPr>
-              <a:t>kv connector 与 MooncakeConnector</a:t>
-            </a:r>
-          </a:p>
-        </p:txBody>
-      </p:sp>
-      <p:sp>
-        <p:nvSpPr>
-          <p:cNvPr id="46" name="Rectangle 45"/>
-          <p:cNvSpPr/>
-          <p:nvPr/>
-        </p:nvSpPr>
-        <p:spPr>
-          <a:xfrm>
-            <a:off x="8351520" y="4206240"/>
-            <a:ext cx="3535680" cy="658368"/>
+            <a:off x="4742688" y="3858768"/>
+            <a:ext cx="3535680" cy="512064"/>
           </a:xfrm>
           <a:prstGeom prst="rect">
             <a:avLst/>
@@ -5628,14 +5501,14 @@
       </p:sp>
       <p:sp>
         <p:nvSpPr>
-          <p:cNvPr id="47" name="TextBox 46"/>
+          <p:cNvPr id="44" name="TextBox 43"/>
           <p:cNvSpPr txBox="1"/>
           <p:nvPr/>
         </p:nvSpPr>
         <p:spPr>
           <a:xfrm>
-            <a:off x="8442960" y="4261103"/>
-            <a:ext cx="3352800" cy="237744"/>
+            <a:off x="4815840" y="3895344"/>
+            <a:ext cx="3389376" cy="219456"/>
           </a:xfrm>
           <a:prstGeom prst="rect">
             <a:avLst/>
@@ -5655,7 +5528,7 @@
               </a:spcAft>
             </a:pPr>
             <a:r>
-              <a:rPr sz="1400" b="1">
+              <a:rPr sz="1300" b="1">
                 <a:solidFill>
                   <a:srgbClr val="FFFFFF"/>
                 </a:solidFill>
@@ -5670,14 +5543,14 @@
       </p:sp>
       <p:sp>
         <p:nvSpPr>
-          <p:cNvPr id="48" name="TextBox 47"/>
+          <p:cNvPr id="45" name="TextBox 44"/>
           <p:cNvSpPr txBox="1"/>
           <p:nvPr/>
         </p:nvSpPr>
         <p:spPr>
           <a:xfrm>
-            <a:off x="8442960" y="4498848"/>
-            <a:ext cx="3352800" cy="310896"/>
+            <a:off x="4815840" y="4114800"/>
+            <a:ext cx="3389376" cy="219456"/>
           </a:xfrm>
           <a:prstGeom prst="rect">
             <a:avLst/>
@@ -5697,7 +5570,7 @@
               </a:spcAft>
             </a:pPr>
             <a:r>
-              <a:rPr sz="1200" b="0">
+              <a:rPr sz="1100" b="0">
                 <a:solidFill>
                   <a:srgbClr val="FFFFFF"/>
                 </a:solidFill>
@@ -5705,7 +5578,134 @@
                 <a:ea typeface="Microsoft YaHei"/>
                 <a:cs typeface="Microsoft YaHei"/>
               </a:rPr>
-              <a:t>Conductor 管位置，Store 做共享池</a:t>
+              <a:t>mooncake_master。Conductor 管 KV 位置。</a:t>
+            </a:r>
+          </a:p>
+        </p:txBody>
+      </p:sp>
+      <p:sp>
+        <p:nvSpPr>
+          <p:cNvPr id="46" name="Rectangle 45"/>
+          <p:cNvSpPr/>
+          <p:nvPr/>
+        </p:nvSpPr>
+        <p:spPr>
+          <a:xfrm>
+            <a:off x="8351520" y="3858768"/>
+            <a:ext cx="3535680" cy="512064"/>
+          </a:xfrm>
+          <a:prstGeom prst="rect">
+            <a:avLst/>
+          </a:prstGeom>
+          <a:solidFill>
+            <a:srgbClr val="0E7A76"/>
+          </a:solidFill>
+          <a:ln>
+            <a:noFill/>
+          </a:ln>
+        </p:spPr>
+        <p:style>
+          <a:lnRef idx="1">
+            <a:schemeClr val="accent1"/>
+          </a:lnRef>
+          <a:fillRef idx="3">
+            <a:schemeClr val="accent1"/>
+          </a:fillRef>
+          <a:effectRef idx="2">
+            <a:schemeClr val="accent1"/>
+          </a:effectRef>
+          <a:fontRef idx="minor">
+            <a:schemeClr val="lt1"/>
+          </a:fontRef>
+        </p:style>
+        <p:txBody>
+          <a:bodyPr rtlCol="0" anchor="ctr"/>
+          <a:lstStyle/>
+          <a:p>
+            <a:pPr algn="ctr"/>
+          </a:p>
+        </p:txBody>
+      </p:sp>
+      <p:sp>
+        <p:nvSpPr>
+          <p:cNvPr id="47" name="TextBox 46"/>
+          <p:cNvSpPr txBox="1"/>
+          <p:nvPr/>
+        </p:nvSpPr>
+        <p:spPr>
+          <a:xfrm>
+            <a:off x="8424672" y="3895344"/>
+            <a:ext cx="3389376" cy="219456"/>
+          </a:xfrm>
+          <a:prstGeom prst="rect">
+            <a:avLst/>
+          </a:prstGeom>
+          <a:noFill/>
+        </p:spPr>
+        <p:txBody>
+          <a:bodyPr wrap="square" lIns="0" rIns="0" tIns="0" bIns="0" anchor="ctr"/>
+          <a:lstStyle/>
+          <a:p>
+            <a:pPr algn="l">
+              <a:spcBef>
+                <a:spcPts val="0"/>
+              </a:spcBef>
+              <a:spcAft>
+                <a:spcPts val="0"/>
+              </a:spcAft>
+            </a:pPr>
+            <a:r>
+              <a:rPr sz="1300" b="1">
+                <a:solidFill>
+                  <a:srgbClr val="FFFFFF"/>
+                </a:solidFill>
+                <a:latin typeface="Microsoft YaHei"/>
+                <a:ea typeface="Microsoft YaHei"/>
+                <a:cs typeface="Microsoft YaHei"/>
+              </a:rPr>
+              <a:t>实例内</a:t>
+            </a:r>
+          </a:p>
+        </p:txBody>
+      </p:sp>
+      <p:sp>
+        <p:nvSpPr>
+          <p:cNvPr id="48" name="TextBox 47"/>
+          <p:cNvSpPr txBox="1"/>
+          <p:nvPr/>
+        </p:nvSpPr>
+        <p:spPr>
+          <a:xfrm>
+            <a:off x="8424672" y="4114800"/>
+            <a:ext cx="3389376" cy="219456"/>
+          </a:xfrm>
+          <a:prstGeom prst="rect">
+            <a:avLst/>
+          </a:prstGeom>
+          <a:noFill/>
+        </p:spPr>
+        <p:txBody>
+          <a:bodyPr wrap="square" lIns="0" rIns="0" tIns="0" bIns="0" anchor="t"/>
+          <a:lstStyle/>
+          <a:p>
+            <a:pPr algn="l">
+              <a:spcBef>
+                <a:spcPts val="0"/>
+              </a:spcBef>
+              <a:spcAft>
+                <a:spcPts val="0"/>
+              </a:spcAft>
+            </a:pPr>
+            <a:r>
+              <a:rPr sz="1100" b="0">
+                <a:solidFill>
+                  <a:srgbClr val="FFFFFF"/>
+                </a:solidFill>
+                <a:latin typeface="Microsoft YaHei"/>
+                <a:ea typeface="Microsoft YaHei"/>
+                <a:cs typeface="Microsoft YaHei"/>
+              </a:rPr>
+              <a:t>Block Manager 与 vLLM 本卡池。另有 YuanRong。</a:t>
             </a:r>
           </a:p>
         </p:txBody>
@@ -5718,8 +5718,558 @@
         </p:nvSpPr>
         <p:spPr>
           <a:xfrm>
-            <a:off x="256032" y="4956048"/>
-            <a:ext cx="841248" cy="384048"/>
+            <a:off x="256032" y="4443984"/>
+            <a:ext cx="841248" cy="585216"/>
+          </a:xfrm>
+          <a:prstGeom prst="rect">
+            <a:avLst/>
+          </a:prstGeom>
+          <a:noFill/>
+        </p:spPr>
+        <p:txBody>
+          <a:bodyPr wrap="square" lIns="0" rIns="0" tIns="0" bIns="0" anchor="ctr"/>
+          <a:lstStyle/>
+          <a:p>
+            <a:pPr algn="l">
+              <a:spcBef>
+                <a:spcPts val="0"/>
+              </a:spcBef>
+              <a:spcAft>
+                <a:spcPts val="0"/>
+              </a:spcAft>
+            </a:pPr>
+            <a:r>
+              <a:rPr sz="1200" b="1">
+                <a:solidFill>
+                  <a:srgbClr val="145A96"/>
+                </a:solidFill>
+                <a:latin typeface="Microsoft YaHei"/>
+                <a:ea typeface="Microsoft YaHei"/>
+                <a:cs typeface="Microsoft YaHei"/>
+              </a:rPr>
+              <a:t>通信</a:t>
+            </a:r>
+          </a:p>
+        </p:txBody>
+      </p:sp>
+      <p:sp>
+        <p:nvSpPr>
+          <p:cNvPr id="50" name="Rectangle 49"/>
+          <p:cNvSpPr/>
+          <p:nvPr/>
+        </p:nvSpPr>
+        <p:spPr>
+          <a:xfrm>
+            <a:off x="1133856" y="4443984"/>
+            <a:ext cx="2633472" cy="585216"/>
+          </a:xfrm>
+          <a:prstGeom prst="rect">
+            <a:avLst/>
+          </a:prstGeom>
+          <a:solidFill>
+            <a:srgbClr val="145A96"/>
+          </a:solidFill>
+          <a:ln>
+            <a:noFill/>
+          </a:ln>
+        </p:spPr>
+        <p:style>
+          <a:lnRef idx="1">
+            <a:schemeClr val="accent1"/>
+          </a:lnRef>
+          <a:fillRef idx="3">
+            <a:schemeClr val="accent1"/>
+          </a:fillRef>
+          <a:effectRef idx="2">
+            <a:schemeClr val="accent1"/>
+          </a:effectRef>
+          <a:fontRef idx="minor">
+            <a:schemeClr val="lt1"/>
+          </a:fontRef>
+        </p:style>
+        <p:txBody>
+          <a:bodyPr rtlCol="0" anchor="ctr"/>
+          <a:lstStyle/>
+          <a:p>
+            <a:pPr algn="ctr"/>
+          </a:p>
+        </p:txBody>
+      </p:sp>
+      <p:sp>
+        <p:nvSpPr>
+          <p:cNvPr id="51" name="TextBox 50"/>
+          <p:cNvSpPr txBox="1"/>
+          <p:nvPr/>
+        </p:nvSpPr>
+        <p:spPr>
+          <a:xfrm>
+            <a:off x="1207008" y="4480560"/>
+            <a:ext cx="2487168" cy="219456"/>
+          </a:xfrm>
+          <a:prstGeom prst="rect">
+            <a:avLst/>
+          </a:prstGeom>
+          <a:noFill/>
+        </p:spPr>
+        <p:txBody>
+          <a:bodyPr wrap="square" lIns="0" rIns="0" tIns="0" bIns="0" anchor="ctr"/>
+          <a:lstStyle/>
+          <a:p>
+            <a:pPr algn="l">
+              <a:spcBef>
+                <a:spcPts val="0"/>
+              </a:spcBef>
+              <a:spcAft>
+                <a:spcPts val="0"/>
+              </a:spcAft>
+            </a:pPr>
+            <a:r>
+              <a:rPr sz="1300" b="1">
+                <a:solidFill>
+                  <a:srgbClr val="FFFFFF"/>
+                </a:solidFill>
+                <a:latin typeface="Microsoft YaHei"/>
+                <a:ea typeface="Microsoft YaHei"/>
+                <a:cs typeface="Microsoft YaHei"/>
+              </a:rPr>
+              <a:t>HCCL</a:t>
+            </a:r>
+          </a:p>
+        </p:txBody>
+      </p:sp>
+      <p:sp>
+        <p:nvSpPr>
+          <p:cNvPr id="52" name="TextBox 51"/>
+          <p:cNvSpPr txBox="1"/>
+          <p:nvPr/>
+        </p:nvSpPr>
+        <p:spPr>
+          <a:xfrm>
+            <a:off x="1207008" y="4700016"/>
+            <a:ext cx="2487168" cy="292608"/>
+          </a:xfrm>
+          <a:prstGeom prst="rect">
+            <a:avLst/>
+          </a:prstGeom>
+          <a:noFill/>
+        </p:spPr>
+        <p:txBody>
+          <a:bodyPr wrap="square" lIns="0" rIns="0" tIns="0" bIns="0" anchor="t"/>
+          <a:lstStyle/>
+          <a:p>
+            <a:pPr algn="l">
+              <a:spcBef>
+                <a:spcPts val="0"/>
+              </a:spcBef>
+              <a:spcAft>
+                <a:spcPts val="0"/>
+              </a:spcAft>
+            </a:pPr>
+            <a:r>
+              <a:rPr sz="1100" b="0">
+                <a:solidFill>
+                  <a:srgbClr val="FFFFFF"/>
+                </a:solidFill>
+                <a:latin typeface="Microsoft YaHei"/>
+                <a:ea typeface="Microsoft YaHei"/>
+                <a:cs typeface="Microsoft YaHei"/>
+              </a:rPr>
+              <a:t>集合通信。服务张量并行和专家并行。</a:t>
+            </a:r>
+          </a:p>
+        </p:txBody>
+      </p:sp>
+      <p:sp>
+        <p:nvSpPr>
+          <p:cNvPr id="53" name="Rectangle 52"/>
+          <p:cNvSpPr/>
+          <p:nvPr/>
+        </p:nvSpPr>
+        <p:spPr>
+          <a:xfrm>
+            <a:off x="3840480" y="4443984"/>
+            <a:ext cx="2633472" cy="585216"/>
+          </a:xfrm>
+          <a:prstGeom prst="rect">
+            <a:avLst/>
+          </a:prstGeom>
+          <a:solidFill>
+            <a:srgbClr val="2E4A6E"/>
+          </a:solidFill>
+          <a:ln>
+            <a:noFill/>
+          </a:ln>
+        </p:spPr>
+        <p:style>
+          <a:lnRef idx="1">
+            <a:schemeClr val="accent1"/>
+          </a:lnRef>
+          <a:fillRef idx="3">
+            <a:schemeClr val="accent1"/>
+          </a:fillRef>
+          <a:effectRef idx="2">
+            <a:schemeClr val="accent1"/>
+          </a:effectRef>
+          <a:fontRef idx="minor">
+            <a:schemeClr val="lt1"/>
+          </a:fontRef>
+        </p:style>
+        <p:txBody>
+          <a:bodyPr rtlCol="0" anchor="ctr"/>
+          <a:lstStyle/>
+          <a:p>
+            <a:pPr algn="ctr"/>
+          </a:p>
+        </p:txBody>
+      </p:sp>
+      <p:sp>
+        <p:nvSpPr>
+          <p:cNvPr id="54" name="TextBox 53"/>
+          <p:cNvSpPr txBox="1"/>
+          <p:nvPr/>
+        </p:nvSpPr>
+        <p:spPr>
+          <a:xfrm>
+            <a:off x="3913632" y="4480560"/>
+            <a:ext cx="2487168" cy="219456"/>
+          </a:xfrm>
+          <a:prstGeom prst="rect">
+            <a:avLst/>
+          </a:prstGeom>
+          <a:noFill/>
+        </p:spPr>
+        <p:txBody>
+          <a:bodyPr wrap="square" lIns="0" rIns="0" tIns="0" bIns="0" anchor="ctr"/>
+          <a:lstStyle/>
+          <a:p>
+            <a:pPr algn="l">
+              <a:spcBef>
+                <a:spcPts val="0"/>
+              </a:spcBef>
+              <a:spcAft>
+                <a:spcPts val="0"/>
+              </a:spcAft>
+            </a:pPr>
+            <a:r>
+              <a:rPr sz="1300" b="1">
+                <a:solidFill>
+                  <a:srgbClr val="FFFFFF"/>
+                </a:solidFill>
+                <a:latin typeface="Microsoft YaHei"/>
+                <a:ea typeface="Microsoft YaHei"/>
+                <a:cs typeface="Microsoft YaHei"/>
+              </a:rPr>
+              <a:t>HCOMM</a:t>
+            </a:r>
+          </a:p>
+        </p:txBody>
+      </p:sp>
+      <p:sp>
+        <p:nvSpPr>
+          <p:cNvPr id="55" name="TextBox 54"/>
+          <p:cNvSpPr txBox="1"/>
+          <p:nvPr/>
+        </p:nvSpPr>
+        <p:spPr>
+          <a:xfrm>
+            <a:off x="3913632" y="4700016"/>
+            <a:ext cx="2487168" cy="292608"/>
+          </a:xfrm>
+          <a:prstGeom prst="rect">
+            <a:avLst/>
+          </a:prstGeom>
+          <a:noFill/>
+        </p:spPr>
+        <p:txBody>
+          <a:bodyPr wrap="square" lIns="0" rIns="0" tIns="0" bIns="0" anchor="t"/>
+          <a:lstStyle/>
+          <a:p>
+            <a:pPr algn="l">
+              <a:spcBef>
+                <a:spcPts val="0"/>
+              </a:spcBef>
+              <a:spcAft>
+                <a:spcPts val="0"/>
+              </a:spcAft>
+            </a:pPr>
+            <a:r>
+              <a:rPr sz="1100" b="0">
+                <a:solidFill>
+                  <a:srgbClr val="FFFFFF"/>
+                </a:solidFill>
+                <a:latin typeface="Microsoft YaHei"/>
+                <a:ea typeface="Microsoft YaHei"/>
+                <a:cs typeface="Microsoft YaHei"/>
+              </a:rPr>
+              <a:t>HCCL 的基础库。控制面与数据面。</a:t>
+            </a:r>
+          </a:p>
+        </p:txBody>
+      </p:sp>
+      <p:sp>
+        <p:nvSpPr>
+          <p:cNvPr id="56" name="Rectangle 55"/>
+          <p:cNvSpPr/>
+          <p:nvPr/>
+        </p:nvSpPr>
+        <p:spPr>
+          <a:xfrm>
+            <a:off x="6547104" y="4443984"/>
+            <a:ext cx="2633472" cy="585216"/>
+          </a:xfrm>
+          <a:prstGeom prst="rect">
+            <a:avLst/>
+          </a:prstGeom>
+          <a:solidFill>
+            <a:srgbClr val="0E7A76"/>
+          </a:solidFill>
+          <a:ln>
+            <a:noFill/>
+          </a:ln>
+        </p:spPr>
+        <p:style>
+          <a:lnRef idx="1">
+            <a:schemeClr val="accent1"/>
+          </a:lnRef>
+          <a:fillRef idx="3">
+            <a:schemeClr val="accent1"/>
+          </a:fillRef>
+          <a:effectRef idx="2">
+            <a:schemeClr val="accent1"/>
+          </a:effectRef>
+          <a:fontRef idx="minor">
+            <a:schemeClr val="lt1"/>
+          </a:fontRef>
+        </p:style>
+        <p:txBody>
+          <a:bodyPr rtlCol="0" anchor="ctr"/>
+          <a:lstStyle/>
+          <a:p>
+            <a:pPr algn="ctr"/>
+          </a:p>
+        </p:txBody>
+      </p:sp>
+      <p:sp>
+        <p:nvSpPr>
+          <p:cNvPr id="57" name="TextBox 56"/>
+          <p:cNvSpPr txBox="1"/>
+          <p:nvPr/>
+        </p:nvSpPr>
+        <p:spPr>
+          <a:xfrm>
+            <a:off x="6620256" y="4480560"/>
+            <a:ext cx="2487168" cy="219456"/>
+          </a:xfrm>
+          <a:prstGeom prst="rect">
+            <a:avLst/>
+          </a:prstGeom>
+          <a:noFill/>
+        </p:spPr>
+        <p:txBody>
+          <a:bodyPr wrap="square" lIns="0" rIns="0" tIns="0" bIns="0" anchor="ctr"/>
+          <a:lstStyle/>
+          <a:p>
+            <a:pPr algn="l">
+              <a:spcBef>
+                <a:spcPts val="0"/>
+              </a:spcBef>
+              <a:spcAft>
+                <a:spcPts val="0"/>
+              </a:spcAft>
+            </a:pPr>
+            <a:r>
+              <a:rPr sz="1300" b="1">
+                <a:solidFill>
+                  <a:srgbClr val="FFFFFF"/>
+                </a:solidFill>
+                <a:latin typeface="Microsoft YaHei"/>
+                <a:ea typeface="Microsoft YaHei"/>
+                <a:cs typeface="Microsoft YaHei"/>
+              </a:rPr>
+              <a:t>HIXL</a:t>
+            </a:r>
+          </a:p>
+        </p:txBody>
+      </p:sp>
+      <p:sp>
+        <p:nvSpPr>
+          <p:cNvPr id="58" name="TextBox 57"/>
+          <p:cNvSpPr txBox="1"/>
+          <p:nvPr/>
+        </p:nvSpPr>
+        <p:spPr>
+          <a:xfrm>
+            <a:off x="6620256" y="4700016"/>
+            <a:ext cx="2487168" cy="292608"/>
+          </a:xfrm>
+          <a:prstGeom prst="rect">
+            <a:avLst/>
+          </a:prstGeom>
+          <a:noFill/>
+        </p:spPr>
+        <p:txBody>
+          <a:bodyPr wrap="square" lIns="0" rIns="0" tIns="0" bIns="0" anchor="t"/>
+          <a:lstStyle/>
+          <a:p>
+            <a:pPr algn="l">
+              <a:spcBef>
+                <a:spcPts val="0"/>
+              </a:spcBef>
+              <a:spcAft>
+                <a:spcPts val="0"/>
+              </a:spcAft>
+            </a:pPr>
+            <a:r>
+              <a:rPr sz="1100" b="0">
+                <a:solidFill>
+                  <a:srgbClr val="FFFFFF"/>
+                </a:solidFill>
+                <a:latin typeface="Microsoft YaHei"/>
+                <a:ea typeface="Microsoft YaHei"/>
+                <a:cs typeface="Microsoft YaHei"/>
+              </a:rPr>
+              <a:t>单边。LLM-DataDist 拉取和推送 KV。</a:t>
+            </a:r>
+          </a:p>
+        </p:txBody>
+      </p:sp>
+      <p:sp>
+        <p:nvSpPr>
+          <p:cNvPr id="59" name="Rectangle 58"/>
+          <p:cNvSpPr/>
+          <p:nvPr/>
+        </p:nvSpPr>
+        <p:spPr>
+          <a:xfrm>
+            <a:off x="9253728" y="4443984"/>
+            <a:ext cx="2633472" cy="585216"/>
+          </a:xfrm>
+          <a:prstGeom prst="rect">
+            <a:avLst/>
+          </a:prstGeom>
+          <a:solidFill>
+            <a:srgbClr val="0E2A47"/>
+          </a:solidFill>
+          <a:ln>
+            <a:noFill/>
+          </a:ln>
+        </p:spPr>
+        <p:style>
+          <a:lnRef idx="1">
+            <a:schemeClr val="accent1"/>
+          </a:lnRef>
+          <a:fillRef idx="3">
+            <a:schemeClr val="accent1"/>
+          </a:fillRef>
+          <a:effectRef idx="2">
+            <a:schemeClr val="accent1"/>
+          </a:effectRef>
+          <a:fontRef idx="minor">
+            <a:schemeClr val="lt1"/>
+          </a:fontRef>
+        </p:style>
+        <p:txBody>
+          <a:bodyPr rtlCol="0" anchor="ctr"/>
+          <a:lstStyle/>
+          <a:p>
+            <a:pPr algn="ctr"/>
+          </a:p>
+        </p:txBody>
+      </p:sp>
+      <p:sp>
+        <p:nvSpPr>
+          <p:cNvPr id="60" name="TextBox 59"/>
+          <p:cNvSpPr txBox="1"/>
+          <p:nvPr/>
+        </p:nvSpPr>
+        <p:spPr>
+          <a:xfrm>
+            <a:off x="9326880" y="4480560"/>
+            <a:ext cx="2487168" cy="219456"/>
+          </a:xfrm>
+          <a:prstGeom prst="rect">
+            <a:avLst/>
+          </a:prstGeom>
+          <a:noFill/>
+        </p:spPr>
+        <p:txBody>
+          <a:bodyPr wrap="square" lIns="0" rIns="0" tIns="0" bIns="0" anchor="ctr"/>
+          <a:lstStyle/>
+          <a:p>
+            <a:pPr algn="l">
+              <a:spcBef>
+                <a:spcPts val="0"/>
+              </a:spcBef>
+              <a:spcAft>
+                <a:spcPts val="0"/>
+              </a:spcAft>
+            </a:pPr>
+            <a:r>
+              <a:rPr sz="1300" b="1">
+                <a:solidFill>
+                  <a:srgbClr val="FFFFFF"/>
+                </a:solidFill>
+                <a:latin typeface="Microsoft YaHei"/>
+                <a:ea typeface="Microsoft YaHei"/>
+                <a:cs typeface="Microsoft YaHei"/>
+              </a:rPr>
+              <a:t>SHMEM</a:t>
+            </a:r>
+          </a:p>
+        </p:txBody>
+      </p:sp>
+      <p:sp>
+        <p:nvSpPr>
+          <p:cNvPr id="61" name="TextBox 60"/>
+          <p:cNvSpPr txBox="1"/>
+          <p:nvPr/>
+        </p:nvSpPr>
+        <p:spPr>
+          <a:xfrm>
+            <a:off x="9326880" y="4700016"/>
+            <a:ext cx="2487168" cy="292608"/>
+          </a:xfrm>
+          <a:prstGeom prst="rect">
+            <a:avLst/>
+          </a:prstGeom>
+          <a:noFill/>
+        </p:spPr>
+        <p:txBody>
+          <a:bodyPr wrap="square" lIns="0" rIns="0" tIns="0" bIns="0" anchor="t"/>
+          <a:lstStyle/>
+          <a:p>
+            <a:pPr algn="l">
+              <a:spcBef>
+                <a:spcPts val="0"/>
+              </a:spcBef>
+              <a:spcAft>
+                <a:spcPts val="0"/>
+              </a:spcAft>
+            </a:pPr>
+            <a:r>
+              <a:rPr sz="1100" b="0">
+                <a:solidFill>
+                  <a:srgbClr val="FFFFFF"/>
+                </a:solidFill>
+                <a:latin typeface="Microsoft YaHei"/>
+                <a:ea typeface="Microsoft YaHei"/>
+                <a:cs typeface="Microsoft YaHei"/>
+              </a:rPr>
+              <a:t>对称内存。卡间单边访问，给定制算子。</a:t>
+            </a:r>
+          </a:p>
+        </p:txBody>
+      </p:sp>
+      <p:sp>
+        <p:nvSpPr>
+          <p:cNvPr id="62" name="TextBox 61"/>
+          <p:cNvSpPr txBox="1"/>
+          <p:nvPr/>
+        </p:nvSpPr>
+        <p:spPr>
+          <a:xfrm>
+            <a:off x="256032" y="5120640"/>
+            <a:ext cx="841248" cy="365760"/>
           </a:xfrm>
           <a:prstGeom prst="rect">
             <a:avLst/>
@@ -5754,14 +6304,14 @@
       </p:sp>
       <p:sp>
         <p:nvSpPr>
-          <p:cNvPr id="50" name="Rectangle 49"/>
+          <p:cNvPr id="63" name="Rectangle 62"/>
           <p:cNvSpPr/>
           <p:nvPr/>
         </p:nvSpPr>
         <p:spPr>
           <a:xfrm>
-            <a:off x="1133856" y="4956048"/>
-            <a:ext cx="1554480" cy="384048"/>
+            <a:off x="1133856" y="5120640"/>
+            <a:ext cx="1554480" cy="365760"/>
           </a:xfrm>
           <a:prstGeom prst="rect">
             <a:avLst/>
@@ -5815,14 +6365,14 @@
       </p:sp>
       <p:sp>
         <p:nvSpPr>
-          <p:cNvPr id="51" name="Rectangle 50"/>
+          <p:cNvPr id="64" name="Rectangle 63"/>
           <p:cNvSpPr/>
           <p:nvPr/>
         </p:nvSpPr>
         <p:spPr>
           <a:xfrm>
-            <a:off x="2688336" y="4956048"/>
-            <a:ext cx="9198864" cy="384048"/>
+            <a:off x="2688336" y="5120640"/>
+            <a:ext cx="9198864" cy="365760"/>
           </a:xfrm>
           <a:prstGeom prst="rect">
             <a:avLst/>
@@ -5858,14 +6408,14 @@
       </p:sp>
       <p:sp>
         <p:nvSpPr>
-          <p:cNvPr id="52" name="TextBox 51"/>
+          <p:cNvPr id="65" name="TextBox 64"/>
           <p:cNvSpPr txBox="1"/>
           <p:nvPr/>
         </p:nvSpPr>
         <p:spPr>
           <a:xfrm>
-            <a:off x="2798064" y="4956048"/>
-            <a:ext cx="9015984" cy="384048"/>
+            <a:off x="2798064" y="5120640"/>
+            <a:ext cx="9015984" cy="365760"/>
           </a:xfrm>
           <a:prstGeom prst="rect">
             <a:avLst/>
@@ -5893,21 +6443,21 @@
                 <a:ea typeface="Microsoft YaHei"/>
                 <a:cs typeface="Microsoft YaHei"/>
               </a:rPr>
-              <a:t>AscendCL、GE、Runtime、算子库、HCCL、DVPP。推理运行包用 NNRT。</a:t>
-            </a:r>
-          </a:p>
-        </p:txBody>
-      </p:sp>
-      <p:sp>
-        <p:nvSpPr>
-          <p:cNvPr id="53" name="TextBox 52"/>
+              <a:t>AscendCL、GE、Runtime、算子库、DVPP。通信四库也在这一层。推理包是 NNRT。</a:t>
+            </a:r>
+          </a:p>
+        </p:txBody>
+      </p:sp>
+      <p:sp>
+        <p:nvSpPr>
+          <p:cNvPr id="66" name="TextBox 65"/>
           <p:cNvSpPr txBox="1"/>
           <p:nvPr/>
         </p:nvSpPr>
         <p:spPr>
           <a:xfrm>
-            <a:off x="256032" y="5394960"/>
-            <a:ext cx="841248" cy="310896"/>
+            <a:off x="256032" y="5541264"/>
+            <a:ext cx="841248" cy="274320"/>
           </a:xfrm>
           <a:prstGeom prst="rect">
             <a:avLst/>
@@ -5942,14 +6492,14 @@
       </p:sp>
       <p:sp>
         <p:nvSpPr>
-          <p:cNvPr id="54" name="Rectangle 53"/>
+          <p:cNvPr id="67" name="Rectangle 66"/>
           <p:cNvSpPr/>
           <p:nvPr/>
         </p:nvSpPr>
         <p:spPr>
           <a:xfrm>
-            <a:off x="1133856" y="5394960"/>
-            <a:ext cx="1554480" cy="310896"/>
+            <a:off x="1133856" y="5541264"/>
+            <a:ext cx="1554480" cy="274320"/>
           </a:xfrm>
           <a:prstGeom prst="rect">
             <a:avLst/>
@@ -6003,14 +6553,14 @@
       </p:sp>
       <p:sp>
         <p:nvSpPr>
-          <p:cNvPr id="55" name="Rectangle 54"/>
+          <p:cNvPr id="68" name="Rectangle 67"/>
           <p:cNvSpPr/>
           <p:nvPr/>
         </p:nvSpPr>
         <p:spPr>
           <a:xfrm>
-            <a:off x="2688336" y="5394960"/>
-            <a:ext cx="9198864" cy="310896"/>
+            <a:off x="2688336" y="5541264"/>
+            <a:ext cx="9198864" cy="274320"/>
           </a:xfrm>
           <a:prstGeom prst="rect">
             <a:avLst/>
@@ -6046,14 +6596,14 @@
       </p:sp>
       <p:sp>
         <p:nvSpPr>
-          <p:cNvPr id="56" name="TextBox 55"/>
+          <p:cNvPr id="69" name="TextBox 68"/>
           <p:cNvSpPr txBox="1"/>
           <p:nvPr/>
         </p:nvSpPr>
         <p:spPr>
           <a:xfrm>
-            <a:off x="2798064" y="5394960"/>
-            <a:ext cx="9015984" cy="310896"/>
+            <a:off x="2798064" y="5541264"/>
+            <a:ext cx="9015984" cy="274320"/>
           </a:xfrm>
           <a:prstGeom prst="rect">
             <a:avLst/>
@@ -6088,14 +6638,14 @@
       </p:sp>
       <p:sp>
         <p:nvSpPr>
-          <p:cNvPr id="57" name="TextBox 56"/>
+          <p:cNvPr id="70" name="TextBox 69"/>
           <p:cNvSpPr txBox="1"/>
           <p:nvPr/>
         </p:nvSpPr>
         <p:spPr>
           <a:xfrm>
-            <a:off x="256032" y="5760720"/>
-            <a:ext cx="841248" cy="310896"/>
+            <a:off x="256032" y="5870448"/>
+            <a:ext cx="841248" cy="274320"/>
           </a:xfrm>
           <a:prstGeom prst="rect">
             <a:avLst/>
@@ -6130,14 +6680,14 @@
       </p:sp>
       <p:sp>
         <p:nvSpPr>
-          <p:cNvPr id="58" name="Rectangle 57"/>
+          <p:cNvPr id="71" name="Rectangle 70"/>
           <p:cNvSpPr/>
           <p:nvPr/>
         </p:nvSpPr>
         <p:spPr>
           <a:xfrm>
-            <a:off x="1133856" y="5760720"/>
-            <a:ext cx="1554480" cy="310896"/>
+            <a:off x="1133856" y="5870448"/>
+            <a:ext cx="1554480" cy="274320"/>
           </a:xfrm>
           <a:prstGeom prst="rect">
             <a:avLst/>
@@ -6191,14 +6741,14 @@
       </p:sp>
       <p:sp>
         <p:nvSpPr>
-          <p:cNvPr id="59" name="Rectangle 58"/>
+          <p:cNvPr id="72" name="Rectangle 71"/>
           <p:cNvSpPr/>
           <p:nvPr/>
         </p:nvSpPr>
         <p:spPr>
           <a:xfrm>
-            <a:off x="2688336" y="5760720"/>
-            <a:ext cx="9198864" cy="310896"/>
+            <a:off x="2688336" y="5870448"/>
+            <a:ext cx="9198864" cy="274320"/>
           </a:xfrm>
           <a:prstGeom prst="rect">
             <a:avLst/>
@@ -6234,14 +6784,14 @@
       </p:sp>
       <p:sp>
         <p:nvSpPr>
-          <p:cNvPr id="60" name="TextBox 59"/>
+          <p:cNvPr id="73" name="TextBox 72"/>
           <p:cNvSpPr txBox="1"/>
           <p:nvPr/>
         </p:nvSpPr>
         <p:spPr>
           <a:xfrm>
-            <a:off x="2798064" y="5760720"/>
-            <a:ext cx="9015984" cy="310896"/>
+            <a:off x="2798064" y="5870448"/>
+            <a:ext cx="9015984" cy="274320"/>
           </a:xfrm>
           <a:prstGeom prst="rect">
             <a:avLst/>
@@ -6276,14 +6826,14 @@
       </p:sp>
       <p:sp>
         <p:nvSpPr>
-          <p:cNvPr id="61" name="TextBox 60"/>
+          <p:cNvPr id="74" name="TextBox 73"/>
           <p:cNvSpPr txBox="1"/>
           <p:nvPr/>
         </p:nvSpPr>
         <p:spPr>
           <a:xfrm>
-            <a:off x="292608" y="6126480"/>
-            <a:ext cx="11612880" cy="585216"/>
+            <a:off x="292608" y="6199632"/>
+            <a:ext cx="11612880" cy="530352"/>
           </a:xfrm>
           <a:prstGeom prst="rect">
             <a:avLst/>
@@ -6311,7 +6861,7 @@
                 <a:ea typeface="Microsoft YaHei"/>
                 <a:cs typeface="Microsoft YaHei"/>
               </a:rPr>
-              <a:t>Mooncake 不是调用链上的一层。Conductor 把 KV 位置交给 Coordinator 做亲和调度；Store 和 connector 挂在引擎侧。</a:t>
+              <a:t>HCCL 走集合，服务模型并行。HIXL 走单边，服务 P 到 D 的 KV。按层池化目前只在 MemCache 上。</a:t>
             </a:r>
           </a:p>
           <a:p>
@@ -6332,7 +6882,7 @@
                 <a:ea typeface="Microsoft YaHei"/>
                 <a:cs typeface="Microsoft YaHei"/>
               </a:rPr>
-              <a:t>池化还可选 MemCache。亲和调度与按层推入共享池是两套配置，不叠在同一次传输上。</a:t>
+              <a:t>HCOMM 是文档里的通信基础库名。MemCache、Mooncake、YuanRong 是池后端，不是三条调用链。</a:t>
             </a:r>
           </a:p>
         </p:txBody>

</xml_diff>

<commit_message>
docs: show HIXL under Mooncake and MemFabric under MemCache
The inference stack slide listed pool backends and CANN libraries as peers.
Draw each pool above its own transfer path, and mark SHMEM as an operator
library outside the default serving path.

Co-authored-by: 69515164-rgb <69515164-rgb@users.noreply.github.com>
</commit_message>
<xml_diff>
--- a/docs/ascend-infer-stack.pptx
+++ b/docs/ascend-infer-stack.pptx
@@ -502,7 +502,7 @@
           <a:lstStyle/>
           <a:p>
             <a:r>
-              <a:t>依据 MindIE 3.1 用户手册 Overview 与 MindIE Motor 3.1 架构说明。MindIE LLM 进入维护，官方建议新部署使用 MindIE Motor 加 vLLM-Ascend。MindIE LLM 自上而下为 Server、LLM Manager、Text Generator、Modeling。LLM Manager 内的 Engine 编排 Scheduler、Executor 和 Worker；Block Manager 管 KV 池。Executor 把调度结果下发给 Text Generator，覆盖跨节点、跨设备。Text Generator 含前处理、Generator、Sampler，并支持可插拔的并行解码。Modeling 提供 ATB Models；开发者架构说明同时支持 ACLGraph 和 ATBGraph。Motor：Coordinator 为数据面入口；Controller 与 NodeManager 为管控面；EngineServer 北向接二者，南向当前仅 vLLM。架构页写明南向接口包括 vLLM、SGLang 和 MindIE，当前版本只支持 vLLM。MindCluster 提供 Kubernetes、PD 分离 CRD 和 Operator，位于调用链外侧。CCAE 可选。CANN 组成沿用方案概述：AscendCL、GE、Runtime、算子库、HCCL、DVPP。推理运行包为 NNRT。KV 池：Motor 3.1 默认后端是 MemCache，由 MetaService 管元数据、LocalService 管 DRAM；Mooncake 用 mooncake_master；还有 YuanRong。vLLM-Ascend 的按层池化目前只支持 MemCache。Mooncake Conductor 给 Coordinator 提供 KV 位置，用于亲和调度。通信库都在 CANN 内。HCCL 是集合通信库，服务张量并行和专家并行；HCOMM 是它的基础库，控制面管拓扑和资源，数据面管搬运和同步。HIXL 是单边通信库，LLM-DataDist 在这里做链路和 KV 的拉取、推送，支持 D2D、D2H、H2D。SHMEM 是对称内存库，给算子开发提供卡间单边访问。用户所说的 HCOM 对应文档名 HCOMM。</a:t>
+              <a:t>依据 MindIE 3.1 用户手册 Overview 与 MindIE Motor 3.1 架构说明。MindIE LLM 进入维护，官方建议新部署使用 MindIE Motor 加 vLLM-Ascend。MindIE LLM 自上而下为 Server、LLM Manager、Text Generator、Modeling。LLM Manager 内的 Engine 编排 Scheduler、Executor 和 Worker；Block Manager 管 KV 池。Executor 把调度结果下发给 Text Generator，覆盖跨节点、跨设备。Text Generator 含前处理、Generator、Sampler，并支持可插拔的并行解码。Modeling 提供 ATB Models；开发者架构说明同时支持 ACLGraph 和 ATBGraph。Motor：Coordinator 为数据面入口；Controller 与 NodeManager 为管控面；EngineServer 北向接二者，南向当前仅 vLLM。架构页写明南向接口包括 vLLM、SGLang 和 MindIE，当前版本只支持 vLLM。MindCluster 提供 Kubernetes、PD 分离 CRD 和 Operator，位于调用链外侧。CCAE 可选。CANN 组成沿用方案概述：AscendCL、GE、Runtime、算子库、HCCL、DVPP。推理运行包为 NNRT。KV 池与传输不是并列关系。AscendStoreConnector.backend 在 memcache、mooncake、yuanrong 里选一个池。MemCache 是 Motor 3.1 默认池：MetaService 管元数据，LocalService 管 DRAM。它的字节走 MemFabric，协议有 device_rdma（A2）、device_sdma（A3）、host_rdma、device_urma（950）、同节点 host_shm。Mooncake 是对象层，mooncake_master 管池。昇腾上的字节走 Ascend Direct（adxl），建在 CANN 的 HIXL 上。ASCEND_USE_ASYNC_TRANSFER 打开 HIXL 异步传输。LLM-DataDist 是 HIXL 上的 KV 接口，做链路和 pull、push，覆盖 D2D、D2H、H2D。Conductor 只是位置索引，Coordinator 用它做亲和调度，字节不经过 Conductor。YuanRong 是第三种池后端。按层池化目前只支持 MemCache。HCCL 是集合通信，服务张量并行和专家并行。HCOMM 是 HCCL 的基础库，控制面管拓扑和资源，数据面管搬运和同步。用户所说的 HCOM 对应文档名 HCOMM。CANN SHMEM（aclshmem）是算子用的对称内存。仓库示例 kv_shuffle 做跨 PE 的 KV 块拷贝，不在默认服务路径上。MindIE 的 SharedMemCommunication 和 layerwise 的 share_memory 使用主机 POSIX 共享内存传控制标志，不是 CANN SHMEM。</a:t>
             </a:r>
           </a:p>
         </p:txBody>
@@ -3601,8 +3601,8 @@
         </p:nvSpPr>
         <p:spPr>
           <a:xfrm>
-            <a:off x="292608" y="365760"/>
-            <a:ext cx="11612880" cy="365760"/>
+            <a:off x="292608" y="347472"/>
+            <a:ext cx="11612880" cy="329184"/>
           </a:xfrm>
           <a:prstGeom prst="rect">
             <a:avLst/>
@@ -3622,7 +3622,7 @@
               </a:spcAft>
             </a:pPr>
             <a:r>
-              <a:rPr sz="2400" b="1">
+              <a:rPr sz="2200" b="1">
                 <a:solidFill>
                   <a:srgbClr val="0E2A47"/>
                 </a:solidFill>
@@ -3630,7 +3630,7 @@
                 <a:ea typeface="Microsoft YaHei"/>
                 <a:cs typeface="Microsoft YaHei"/>
               </a:rPr>
-              <a:t>两条推理路径在 CANN 汇合，下面共用 HDK 和 NPU</a:t>
+              <a:t>Mooncake 的字节走 HIXL，MemCache 的字节走 MemFabric</a:t>
             </a:r>
           </a:p>
         </p:txBody>
@@ -3643,8 +3643,8 @@
         </p:nvSpPr>
         <p:spPr>
           <a:xfrm>
-            <a:off x="292608" y="768096"/>
-            <a:ext cx="11612880" cy="292608"/>
+            <a:off x="292608" y="694944"/>
+            <a:ext cx="11612880" cy="274320"/>
           </a:xfrm>
           <a:prstGeom prst="rect">
             <a:avLst/>
@@ -3664,7 +3664,7 @@
               </a:spcAft>
             </a:pPr>
             <a:r>
-              <a:rPr sz="1500" b="0">
+              <a:rPr sz="1400" b="0">
                 <a:solidFill>
                   <a:srgbClr val="1C242E"/>
                 </a:solidFill>
@@ -3672,7 +3672,7 @@
                 <a:ea typeface="Microsoft YaHei"/>
                 <a:cs typeface="Microsoft YaHei"/>
               </a:rPr>
-              <a:t>新部署走 MindIE Motor，南向当前是 vLLM-Ascend。MindIE LLM 仍保留原生层次，已进入维护。</a:t>
+              <a:t>两条服务在 CANN 汇合。默认推理不调用 SHMEM。HCOMM 是 HCCL 的基础库。</a:t>
             </a:r>
           </a:p>
         </p:txBody>
@@ -3685,8 +3685,8 @@
         </p:nvSpPr>
         <p:spPr>
           <a:xfrm>
-            <a:off x="256032" y="1115568"/>
-            <a:ext cx="841248" cy="329184"/>
+            <a:off x="256032" y="1024128"/>
+            <a:ext cx="841248" cy="274320"/>
           </a:xfrm>
           <a:prstGeom prst="rect">
             <a:avLst/>
@@ -3706,7 +3706,7 @@
               </a:spcAft>
             </a:pPr>
             <a:r>
-              <a:rPr sz="1300" b="1">
+              <a:rPr sz="1200" b="1">
                 <a:solidFill>
                   <a:srgbClr val="7A541C"/>
                 </a:solidFill>
@@ -3727,8 +3727,8 @@
         </p:nvSpPr>
         <p:spPr>
           <a:xfrm>
-            <a:off x="1133856" y="1115568"/>
-            <a:ext cx="1554480" cy="329184"/>
+            <a:off x="1133856" y="1024128"/>
+            <a:ext cx="1554480" cy="274320"/>
           </a:xfrm>
           <a:prstGeom prst="rect">
             <a:avLst/>
@@ -3788,8 +3788,8 @@
         </p:nvSpPr>
         <p:spPr>
           <a:xfrm>
-            <a:off x="2688336" y="1115568"/>
-            <a:ext cx="9198864" cy="329184"/>
+            <a:off x="2688336" y="1024128"/>
+            <a:ext cx="9198864" cy="274320"/>
           </a:xfrm>
           <a:prstGeom prst="rect">
             <a:avLst/>
@@ -3831,8 +3831,8 @@
         </p:nvSpPr>
         <p:spPr>
           <a:xfrm>
-            <a:off x="2798064" y="1115568"/>
-            <a:ext cx="9015984" cy="329184"/>
+            <a:off x="2798064" y="1024128"/>
+            <a:ext cx="9015984" cy="274320"/>
           </a:xfrm>
           <a:prstGeom prst="rect">
             <a:avLst/>
@@ -3873,8 +3873,8 @@
         </p:nvSpPr>
         <p:spPr>
           <a:xfrm>
-            <a:off x="256032" y="1517904"/>
-            <a:ext cx="841248" cy="2267712"/>
+            <a:off x="256032" y="1353312"/>
+            <a:ext cx="841248" cy="1975104"/>
           </a:xfrm>
           <a:prstGeom prst="rect">
             <a:avLst/>
@@ -3894,7 +3894,7 @@
               </a:spcAft>
             </a:pPr>
             <a:r>
-              <a:rPr sz="1300" b="1">
+              <a:rPr sz="1200" b="1">
                 <a:solidFill>
                   <a:srgbClr val="0E7A76"/>
                 </a:solidFill>
@@ -3915,8 +3915,8 @@
         </p:nvSpPr>
         <p:spPr>
           <a:xfrm>
-            <a:off x="1133856" y="1517904"/>
-            <a:ext cx="5321808" cy="2267712"/>
+            <a:off x="1133856" y="1353312"/>
+            <a:ext cx="5321808" cy="1975104"/>
           </a:xfrm>
           <a:prstGeom prst="rect">
             <a:avLst/>
@@ -3960,7 +3960,7 @@
         </p:nvSpPr>
         <p:spPr>
           <a:xfrm>
-            <a:off x="1133856" y="1517904"/>
+            <a:off x="1133856" y="1353312"/>
             <a:ext cx="5321808" cy="310896"/>
           </a:xfrm>
           <a:prstGeom prst="rect">
@@ -4008,7 +4008,7 @@
                 <a:ea typeface="Microsoft YaHei"/>
                 <a:cs typeface="Microsoft YaHei"/>
               </a:rPr>
-              <a:t>路径 A  ·  MindIE LLM 原生引擎</a:t>
+              <a:t>路径 A  ·  MindIE LLM</a:t>
             </a:r>
           </a:p>
         </p:txBody>
@@ -4021,8 +4021,8 @@
         </p:nvSpPr>
         <p:spPr>
           <a:xfrm>
-            <a:off x="1207008" y="1901952"/>
-            <a:ext cx="1627632" cy="411480"/>
+            <a:off x="1207008" y="1737360"/>
+            <a:ext cx="1627632" cy="338328"/>
           </a:xfrm>
           <a:prstGeom prst="rect">
             <a:avLst/>
@@ -4082,8 +4082,8 @@
         </p:nvSpPr>
         <p:spPr>
           <a:xfrm>
-            <a:off x="2834640" y="1901952"/>
-            <a:ext cx="3547872" cy="411480"/>
+            <a:off x="2834640" y="1737360"/>
+            <a:ext cx="3547872" cy="338328"/>
           </a:xfrm>
           <a:prstGeom prst="rect">
             <a:avLst/>
@@ -4125,8 +4125,8 @@
         </p:nvSpPr>
         <p:spPr>
           <a:xfrm>
-            <a:off x="2926080" y="1901952"/>
-            <a:ext cx="3419856" cy="411480"/>
+            <a:off x="2926080" y="1737360"/>
+            <a:ext cx="3419856" cy="338328"/>
           </a:xfrm>
           <a:prstGeom prst="rect">
             <a:avLst/>
@@ -4154,7 +4154,7 @@
                 <a:ea typeface="Microsoft YaHei"/>
                 <a:cs typeface="Microsoft YaHei"/>
               </a:rPr>
-              <a:t>Endpoint 兼容 OpenAI、vLLM、Triton、TGI。</a:t>
+              <a:t>OpenAI、vLLM、Triton、TGI。</a:t>
             </a:r>
           </a:p>
         </p:txBody>
@@ -4167,8 +4167,8 @@
         </p:nvSpPr>
         <p:spPr>
           <a:xfrm>
-            <a:off x="1207008" y="2368296"/>
-            <a:ext cx="1627632" cy="411480"/>
+            <a:off x="1207008" y="2130552"/>
+            <a:ext cx="1627632" cy="338328"/>
           </a:xfrm>
           <a:prstGeom prst="rect">
             <a:avLst/>
@@ -4228,8 +4228,8 @@
         </p:nvSpPr>
         <p:spPr>
           <a:xfrm>
-            <a:off x="2834640" y="2368296"/>
-            <a:ext cx="3547872" cy="411480"/>
+            <a:off x="2834640" y="2130552"/>
+            <a:ext cx="3547872" cy="338328"/>
           </a:xfrm>
           <a:prstGeom prst="rect">
             <a:avLst/>
@@ -4271,8 +4271,8 @@
         </p:nvSpPr>
         <p:spPr>
           <a:xfrm>
-            <a:off x="2926080" y="2368296"/>
-            <a:ext cx="3419856" cy="411480"/>
+            <a:off x="2926080" y="2130552"/>
+            <a:ext cx="3419856" cy="338328"/>
           </a:xfrm>
           <a:prstGeom prst="rect">
             <a:avLst/>
@@ -4300,7 +4300,7 @@
                 <a:ea typeface="Microsoft YaHei"/>
                 <a:cs typeface="Microsoft YaHei"/>
               </a:rPr>
-              <a:t>连续组批。Engine 内含 Scheduler。</a:t>
+              <a:t>连续组批。Engine 含 Scheduler。</a:t>
             </a:r>
           </a:p>
         </p:txBody>
@@ -4313,8 +4313,8 @@
         </p:nvSpPr>
         <p:spPr>
           <a:xfrm>
-            <a:off x="1207008" y="2834640"/>
-            <a:ext cx="1627632" cy="411480"/>
+            <a:off x="1207008" y="2523744"/>
+            <a:ext cx="1627632" cy="338328"/>
           </a:xfrm>
           <a:prstGeom prst="rect">
             <a:avLst/>
@@ -4374,8 +4374,8 @@
         </p:nvSpPr>
         <p:spPr>
           <a:xfrm>
-            <a:off x="2834640" y="2834640"/>
-            <a:ext cx="3547872" cy="411480"/>
+            <a:off x="2834640" y="2523744"/>
+            <a:ext cx="3547872" cy="338328"/>
           </a:xfrm>
           <a:prstGeom prst="rect">
             <a:avLst/>
@@ -4417,8 +4417,8 @@
         </p:nvSpPr>
         <p:spPr>
           <a:xfrm>
-            <a:off x="2926080" y="2834640"/>
-            <a:ext cx="3419856" cy="411480"/>
+            <a:off x="2926080" y="2523744"/>
+            <a:ext cx="3419856" cy="338328"/>
           </a:xfrm>
           <a:prstGeom prst="rect">
             <a:avLst/>
@@ -4446,7 +4446,7 @@
                 <a:ea typeface="Microsoft YaHei"/>
                 <a:cs typeface="Microsoft YaHei"/>
               </a:rPr>
-              <a:t>自回归执行。Executor 负责跨节点下发。</a:t>
+              <a:t>自回归。Executor 跨节点下发。</a:t>
             </a:r>
           </a:p>
         </p:txBody>
@@ -4459,8 +4459,8 @@
         </p:nvSpPr>
         <p:spPr>
           <a:xfrm>
-            <a:off x="1207008" y="3300984"/>
-            <a:ext cx="1627632" cy="411480"/>
+            <a:off x="1207008" y="2916936"/>
+            <a:ext cx="1627632" cy="338328"/>
           </a:xfrm>
           <a:prstGeom prst="rect">
             <a:avLst/>
@@ -4520,8 +4520,8 @@
         </p:nvSpPr>
         <p:spPr>
           <a:xfrm>
-            <a:off x="2834640" y="3300984"/>
-            <a:ext cx="3547872" cy="411480"/>
+            <a:off x="2834640" y="2916936"/>
+            <a:ext cx="3547872" cy="338328"/>
           </a:xfrm>
           <a:prstGeom prst="rect">
             <a:avLst/>
@@ -4563,8 +4563,8 @@
         </p:nvSpPr>
         <p:spPr>
           <a:xfrm>
-            <a:off x="2926080" y="3300984"/>
-            <a:ext cx="3419856" cy="411480"/>
+            <a:off x="2926080" y="2916936"/>
+            <a:ext cx="3419856" cy="338328"/>
           </a:xfrm>
           <a:prstGeom prst="rect">
             <a:avLst/>
@@ -4605,8 +4605,8 @@
         </p:nvSpPr>
         <p:spPr>
           <a:xfrm>
-            <a:off x="6565392" y="1517904"/>
-            <a:ext cx="5321808" cy="2267712"/>
+            <a:off x="6565392" y="1353312"/>
+            <a:ext cx="5321808" cy="1975104"/>
           </a:xfrm>
           <a:prstGeom prst="rect">
             <a:avLst/>
@@ -4650,7 +4650,7 @@
         </p:nvSpPr>
         <p:spPr>
           <a:xfrm>
-            <a:off x="6565392" y="1517904"/>
+            <a:off x="6565392" y="1353312"/>
             <a:ext cx="5321808" cy="310896"/>
           </a:xfrm>
           <a:prstGeom prst="rect">
@@ -4711,8 +4711,8 @@
         </p:nvSpPr>
         <p:spPr>
           <a:xfrm>
-            <a:off x="6638544" y="1901952"/>
-            <a:ext cx="1627632" cy="411480"/>
+            <a:off x="6638544" y="1737360"/>
+            <a:ext cx="1627632" cy="338328"/>
           </a:xfrm>
           <a:prstGeom prst="rect">
             <a:avLst/>
@@ -4772,8 +4772,8 @@
         </p:nvSpPr>
         <p:spPr>
           <a:xfrm>
-            <a:off x="8266176" y="1901952"/>
-            <a:ext cx="3547872" cy="411480"/>
+            <a:off x="8266176" y="1737360"/>
+            <a:ext cx="3547872" cy="338328"/>
           </a:xfrm>
           <a:prstGeom prst="rect">
             <a:avLst/>
@@ -4815,8 +4815,8 @@
         </p:nvSpPr>
         <p:spPr>
           <a:xfrm>
-            <a:off x="8357616" y="1901952"/>
-            <a:ext cx="3419856" cy="411480"/>
+            <a:off x="8357616" y="1737360"/>
+            <a:ext cx="3419856" cy="338328"/>
           </a:xfrm>
           <a:prstGeom prst="rect">
             <a:avLst/>
@@ -4857,8 +4857,8 @@
         </p:nvSpPr>
         <p:spPr>
           <a:xfrm>
-            <a:off x="6638544" y="2368296"/>
-            <a:ext cx="1627632" cy="411480"/>
+            <a:off x="6638544" y="2130552"/>
+            <a:ext cx="1627632" cy="338328"/>
           </a:xfrm>
           <a:prstGeom prst="rect">
             <a:avLst/>
@@ -4918,8 +4918,8 @@
         </p:nvSpPr>
         <p:spPr>
           <a:xfrm>
-            <a:off x="8266176" y="2368296"/>
-            <a:ext cx="3547872" cy="411480"/>
+            <a:off x="8266176" y="2130552"/>
+            <a:ext cx="3547872" cy="338328"/>
           </a:xfrm>
           <a:prstGeom prst="rect">
             <a:avLst/>
@@ -4961,8 +4961,8 @@
         </p:nvSpPr>
         <p:spPr>
           <a:xfrm>
-            <a:off x="8357616" y="2368296"/>
-            <a:ext cx="3419856" cy="411480"/>
+            <a:off x="8357616" y="2130552"/>
+            <a:ext cx="3419856" cy="338328"/>
           </a:xfrm>
           <a:prstGeom prst="rect">
             <a:avLst/>
@@ -5003,8 +5003,8 @@
         </p:nvSpPr>
         <p:spPr>
           <a:xfrm>
-            <a:off x="6638544" y="2834640"/>
-            <a:ext cx="1627632" cy="411480"/>
+            <a:off x="6638544" y="2523744"/>
+            <a:ext cx="1627632" cy="338328"/>
           </a:xfrm>
           <a:prstGeom prst="rect">
             <a:avLst/>
@@ -5064,8 +5064,8 @@
         </p:nvSpPr>
         <p:spPr>
           <a:xfrm>
-            <a:off x="8266176" y="2834640"/>
-            <a:ext cx="3547872" cy="411480"/>
+            <a:off x="8266176" y="2523744"/>
+            <a:ext cx="3547872" cy="338328"/>
           </a:xfrm>
           <a:prstGeom prst="rect">
             <a:avLst/>
@@ -5107,8 +5107,8 @@
         </p:nvSpPr>
         <p:spPr>
           <a:xfrm>
-            <a:off x="8357616" y="2834640"/>
-            <a:ext cx="3419856" cy="411480"/>
+            <a:off x="8357616" y="2523744"/>
+            <a:ext cx="3419856" cy="338328"/>
           </a:xfrm>
           <a:prstGeom prst="rect">
             <a:avLst/>
@@ -5136,7 +5136,7 @@
                 <a:ea typeface="Microsoft YaHei"/>
                 <a:cs typeface="Microsoft YaHei"/>
               </a:rPr>
-              <a:t>北向接 Coordinator 和 Controller。</a:t>
+              <a:t>北向接 Coordinator、Controller。</a:t>
             </a:r>
           </a:p>
         </p:txBody>
@@ -5149,8 +5149,8 @@
         </p:nvSpPr>
         <p:spPr>
           <a:xfrm>
-            <a:off x="6638544" y="3300984"/>
-            <a:ext cx="1627632" cy="411480"/>
+            <a:off x="6638544" y="2916936"/>
+            <a:ext cx="1627632" cy="338328"/>
           </a:xfrm>
           <a:prstGeom prst="rect">
             <a:avLst/>
@@ -5210,8 +5210,8 @@
         </p:nvSpPr>
         <p:spPr>
           <a:xfrm>
-            <a:off x="8266176" y="3300984"/>
-            <a:ext cx="3547872" cy="411480"/>
+            <a:off x="8266176" y="2916936"/>
+            <a:ext cx="3547872" cy="338328"/>
           </a:xfrm>
           <a:prstGeom prst="rect">
             <a:avLst/>
@@ -5253,8 +5253,8 @@
         </p:nvSpPr>
         <p:spPr>
           <a:xfrm>
-            <a:off x="8357616" y="3300984"/>
-            <a:ext cx="3419856" cy="411480"/>
+            <a:off x="8357616" y="2916936"/>
+            <a:ext cx="3419856" cy="338328"/>
           </a:xfrm>
           <a:prstGeom prst="rect">
             <a:avLst/>
@@ -5282,7 +5282,7 @@
                 <a:ea typeface="Microsoft YaHei"/>
                 <a:cs typeface="Microsoft YaHei"/>
               </a:rPr>
-              <a:t>当前唯一南向。前向和实例内组批。</a:t>
+              <a:t>当前唯一南向。前向与组批。</a:t>
             </a:r>
           </a:p>
         </p:txBody>
@@ -5295,8 +5295,8 @@
         </p:nvSpPr>
         <p:spPr>
           <a:xfrm>
-            <a:off x="256032" y="3858768"/>
-            <a:ext cx="841248" cy="512064"/>
+            <a:off x="256032" y="3401568"/>
+            <a:ext cx="841248" cy="950976"/>
           </a:xfrm>
           <a:prstGeom prst="rect">
             <a:avLst/>
@@ -5324,7 +5324,7 @@
                 <a:ea typeface="Microsoft YaHei"/>
                 <a:cs typeface="Microsoft YaHei"/>
               </a:rPr>
-              <a:t>KV 池</a:t>
+              <a:t>KV</a:t>
             </a:r>
           </a:p>
         </p:txBody>
@@ -5337,8 +5337,8 @@
         </p:nvSpPr>
         <p:spPr>
           <a:xfrm>
-            <a:off x="1133856" y="3858768"/>
-            <a:ext cx="3535680" cy="512064"/>
+            <a:off x="1133856" y="3401568"/>
+            <a:ext cx="3523488" cy="384048"/>
           </a:xfrm>
           <a:prstGeom prst="rect">
             <a:avLst/>
@@ -5380,8 +5380,8 @@
         </p:nvSpPr>
         <p:spPr>
           <a:xfrm>
-            <a:off x="1207008" y="3895344"/>
-            <a:ext cx="3389376" cy="219456"/>
+            <a:off x="1207008" y="3410712"/>
+            <a:ext cx="3377184" cy="182880"/>
           </a:xfrm>
           <a:prstGeom prst="rect">
             <a:avLst/>
@@ -5409,7 +5409,7 @@
                 <a:ea typeface="Microsoft YaHei"/>
                 <a:cs typeface="Microsoft YaHei"/>
               </a:rPr>
-              <a:t>MemCache</a:t>
+              <a:t>池  MemCache</a:t>
             </a:r>
           </a:p>
         </p:txBody>
@@ -5422,8 +5422,8 @@
         </p:nvSpPr>
         <p:spPr>
           <a:xfrm>
-            <a:off x="1207008" y="4114800"/>
-            <a:ext cx="3389376" cy="219456"/>
+            <a:off x="1207008" y="3593592"/>
+            <a:ext cx="3377184" cy="182880"/>
           </a:xfrm>
           <a:prstGeom prst="rect">
             <a:avLst/>
@@ -5431,7 +5431,7 @@
           <a:noFill/>
         </p:spPr>
         <p:txBody>
-          <a:bodyPr wrap="square" lIns="0" rIns="0" tIns="0" bIns="0" anchor="t"/>
+          <a:bodyPr wrap="square" lIns="0" rIns="0" tIns="0" bIns="0" anchor="ctr"/>
           <a:lstStyle/>
           <a:p>
             <a:pPr algn="l">
@@ -5458,20 +5458,20 @@
       </p:sp>
       <p:sp>
         <p:nvSpPr>
-          <p:cNvPr id="43" name="Rectangle 42"/>
+          <p:cNvPr id="43" name="Down Arrow 42"/>
           <p:cNvSpPr/>
           <p:nvPr/>
         </p:nvSpPr>
         <p:spPr>
           <a:xfrm>
-            <a:off x="4742688" y="3858768"/>
-            <a:ext cx="3535680" cy="512064"/>
-          </a:xfrm>
-          <a:prstGeom prst="rect">
+            <a:off x="2813304" y="3785616"/>
+            <a:ext cx="164592" cy="146304"/>
+          </a:xfrm>
+          <a:prstGeom prst="downArrow">
             <a:avLst/>
           </a:prstGeom>
           <a:solidFill>
-            <a:srgbClr val="7A541C"/>
+            <a:srgbClr val="0E7A76"/>
           </a:solidFill>
           <a:ln>
             <a:noFill/>
@@ -5501,14 +5501,57 @@
       </p:sp>
       <p:sp>
         <p:nvSpPr>
-          <p:cNvPr id="44" name="TextBox 43"/>
+          <p:cNvPr id="44" name="Rectangle 43"/>
+          <p:cNvSpPr/>
+          <p:nvPr/>
+        </p:nvSpPr>
+        <p:spPr>
+          <a:xfrm>
+            <a:off x="1133856" y="3931920"/>
+            <a:ext cx="3523488" cy="420624"/>
+          </a:xfrm>
+          <a:prstGeom prst="rect">
+            <a:avLst/>
+          </a:prstGeom>
+          <a:solidFill>
+            <a:srgbClr val="0E7A76"/>
+          </a:solidFill>
+          <a:ln>
+            <a:noFill/>
+          </a:ln>
+        </p:spPr>
+        <p:style>
+          <a:lnRef idx="1">
+            <a:schemeClr val="accent1"/>
+          </a:lnRef>
+          <a:fillRef idx="3">
+            <a:schemeClr val="accent1"/>
+          </a:fillRef>
+          <a:effectRef idx="2">
+            <a:schemeClr val="accent1"/>
+          </a:effectRef>
+          <a:fontRef idx="minor">
+            <a:schemeClr val="lt1"/>
+          </a:fontRef>
+        </p:style>
+        <p:txBody>
+          <a:bodyPr rtlCol="0" anchor="ctr"/>
+          <a:lstStyle/>
+          <a:p>
+            <a:pPr algn="ctr"/>
+          </a:p>
+        </p:txBody>
+      </p:sp>
+      <p:sp>
+        <p:nvSpPr>
+          <p:cNvPr id="45" name="TextBox 44"/>
           <p:cNvSpPr txBox="1"/>
           <p:nvPr/>
         </p:nvSpPr>
         <p:spPr>
           <a:xfrm>
-            <a:off x="4815840" y="3895344"/>
-            <a:ext cx="3389376" cy="219456"/>
+            <a:off x="1207008" y="3950208"/>
+            <a:ext cx="3377184" cy="182880"/>
           </a:xfrm>
           <a:prstGeom prst="rect">
             <a:avLst/>
@@ -5536,21 +5579,21 @@
                 <a:ea typeface="Microsoft YaHei"/>
                 <a:cs typeface="Microsoft YaHei"/>
               </a:rPr>
-              <a:t>Mooncake</a:t>
-            </a:r>
-          </a:p>
-        </p:txBody>
-      </p:sp>
-      <p:sp>
-        <p:nvSpPr>
-          <p:cNvPr id="45" name="TextBox 44"/>
+              <a:t>传输  MemFabric</a:t>
+            </a:r>
+          </a:p>
+        </p:txBody>
+      </p:sp>
+      <p:sp>
+        <p:nvSpPr>
+          <p:cNvPr id="46" name="TextBox 45"/>
           <p:cNvSpPr txBox="1"/>
           <p:nvPr/>
         </p:nvSpPr>
         <p:spPr>
           <a:xfrm>
-            <a:off x="4815840" y="4114800"/>
-            <a:ext cx="3389376" cy="219456"/>
+            <a:off x="1207008" y="4133088"/>
+            <a:ext cx="3377184" cy="201168"/>
           </a:xfrm>
           <a:prstGeom prst="rect">
             <a:avLst/>
@@ -5558,7 +5601,7 @@
           <a:noFill/>
         </p:spPr>
         <p:txBody>
-          <a:bodyPr wrap="square" lIns="0" rIns="0" tIns="0" bIns="0" anchor="t"/>
+          <a:bodyPr wrap="square" lIns="0" rIns="0" tIns="0" bIns="0" anchor="ctr"/>
           <a:lstStyle/>
           <a:p>
             <a:pPr algn="l">
@@ -5578,27 +5621,27 @@
                 <a:ea typeface="Microsoft YaHei"/>
                 <a:cs typeface="Microsoft YaHei"/>
               </a:rPr>
-              <a:t>mooncake_master。Conductor 管 KV 位置。</a:t>
-            </a:r>
-          </a:p>
-        </p:txBody>
-      </p:sp>
-      <p:sp>
-        <p:nvSpPr>
-          <p:cNvPr id="46" name="Rectangle 45"/>
+              <a:t>rdma、sdma、urma、host_shm。</a:t>
+            </a:r>
+          </a:p>
+        </p:txBody>
+      </p:sp>
+      <p:sp>
+        <p:nvSpPr>
+          <p:cNvPr id="47" name="Rectangle 46"/>
           <p:cNvSpPr/>
           <p:nvPr/>
         </p:nvSpPr>
         <p:spPr>
           <a:xfrm>
-            <a:off x="8351520" y="3858768"/>
-            <a:ext cx="3535680" cy="512064"/>
+            <a:off x="4748784" y="3401568"/>
+            <a:ext cx="3523488" cy="384048"/>
           </a:xfrm>
           <a:prstGeom prst="rect">
             <a:avLst/>
           </a:prstGeom>
           <a:solidFill>
-            <a:srgbClr val="0E7A76"/>
+            <a:srgbClr val="7A541C"/>
           </a:solidFill>
           <a:ln>
             <a:noFill/>
@@ -5628,14 +5671,14 @@
       </p:sp>
       <p:sp>
         <p:nvSpPr>
-          <p:cNvPr id="47" name="TextBox 46"/>
+          <p:cNvPr id="48" name="TextBox 47"/>
           <p:cNvSpPr txBox="1"/>
           <p:nvPr/>
         </p:nvSpPr>
         <p:spPr>
           <a:xfrm>
-            <a:off x="8424672" y="3895344"/>
-            <a:ext cx="3389376" cy="219456"/>
+            <a:off x="4821936" y="3410712"/>
+            <a:ext cx="3377184" cy="182880"/>
           </a:xfrm>
           <a:prstGeom prst="rect">
             <a:avLst/>
@@ -5663,21 +5706,21 @@
                 <a:ea typeface="Microsoft YaHei"/>
                 <a:cs typeface="Microsoft YaHei"/>
               </a:rPr>
-              <a:t>实例内</a:t>
-            </a:r>
-          </a:p>
-        </p:txBody>
-      </p:sp>
-      <p:sp>
-        <p:nvSpPr>
-          <p:cNvPr id="48" name="TextBox 47"/>
+              <a:t>池  Mooncake</a:t>
+            </a:r>
+          </a:p>
+        </p:txBody>
+      </p:sp>
+      <p:sp>
+        <p:nvSpPr>
+          <p:cNvPr id="49" name="TextBox 48"/>
           <p:cNvSpPr txBox="1"/>
           <p:nvPr/>
         </p:nvSpPr>
         <p:spPr>
           <a:xfrm>
-            <a:off x="8424672" y="4114800"/>
-            <a:ext cx="3389376" cy="219456"/>
+            <a:off x="4821936" y="3593592"/>
+            <a:ext cx="3377184" cy="182880"/>
           </a:xfrm>
           <a:prstGeom prst="rect">
             <a:avLst/>
@@ -5685,7 +5728,7 @@
           <a:noFill/>
         </p:spPr>
         <p:txBody>
-          <a:bodyPr wrap="square" lIns="0" rIns="0" tIns="0" bIns="0" anchor="t"/>
+          <a:bodyPr wrap="square" lIns="0" rIns="0" tIns="0" bIns="0" anchor="ctr"/>
           <a:lstStyle/>
           <a:p>
             <a:pPr algn="l">
@@ -5705,21 +5748,488 @@
                 <a:ea typeface="Microsoft YaHei"/>
                 <a:cs typeface="Microsoft YaHei"/>
               </a:rPr>
-              <a:t>Block Manager 与 vLLM 本卡池。另有 YuanRong。</a:t>
-            </a:r>
-          </a:p>
-        </p:txBody>
-      </p:sp>
-      <p:sp>
-        <p:nvSpPr>
-          <p:cNvPr id="49" name="TextBox 48"/>
+              <a:t>对象层。Conductor 只记位置。</a:t>
+            </a:r>
+          </a:p>
+        </p:txBody>
+      </p:sp>
+      <p:sp>
+        <p:nvSpPr>
+          <p:cNvPr id="50" name="Down Arrow 49"/>
+          <p:cNvSpPr/>
+          <p:nvPr/>
+        </p:nvSpPr>
+        <p:spPr>
+          <a:xfrm>
+            <a:off x="6428232" y="3785616"/>
+            <a:ext cx="164592" cy="146304"/>
+          </a:xfrm>
+          <a:prstGeom prst="downArrow">
+            <a:avLst/>
+          </a:prstGeom>
+          <a:solidFill>
+            <a:srgbClr val="145A96"/>
+          </a:solidFill>
+          <a:ln>
+            <a:noFill/>
+          </a:ln>
+        </p:spPr>
+        <p:style>
+          <a:lnRef idx="1">
+            <a:schemeClr val="accent1"/>
+          </a:lnRef>
+          <a:fillRef idx="3">
+            <a:schemeClr val="accent1"/>
+          </a:fillRef>
+          <a:effectRef idx="2">
+            <a:schemeClr val="accent1"/>
+          </a:effectRef>
+          <a:fontRef idx="minor">
+            <a:schemeClr val="lt1"/>
+          </a:fontRef>
+        </p:style>
+        <p:txBody>
+          <a:bodyPr rtlCol="0" anchor="ctr"/>
+          <a:lstStyle/>
+          <a:p>
+            <a:pPr algn="ctr"/>
+          </a:p>
+        </p:txBody>
+      </p:sp>
+      <p:sp>
+        <p:nvSpPr>
+          <p:cNvPr id="51" name="Rectangle 50"/>
+          <p:cNvSpPr/>
+          <p:nvPr/>
+        </p:nvSpPr>
+        <p:spPr>
+          <a:xfrm>
+            <a:off x="4748784" y="3931920"/>
+            <a:ext cx="3523488" cy="420624"/>
+          </a:xfrm>
+          <a:prstGeom prst="rect">
+            <a:avLst/>
+          </a:prstGeom>
+          <a:solidFill>
+            <a:srgbClr val="145A96"/>
+          </a:solidFill>
+          <a:ln>
+            <a:noFill/>
+          </a:ln>
+        </p:spPr>
+        <p:style>
+          <a:lnRef idx="1">
+            <a:schemeClr val="accent1"/>
+          </a:lnRef>
+          <a:fillRef idx="3">
+            <a:schemeClr val="accent1"/>
+          </a:fillRef>
+          <a:effectRef idx="2">
+            <a:schemeClr val="accent1"/>
+          </a:effectRef>
+          <a:fontRef idx="minor">
+            <a:schemeClr val="lt1"/>
+          </a:fontRef>
+        </p:style>
+        <p:txBody>
+          <a:bodyPr rtlCol="0" anchor="ctr"/>
+          <a:lstStyle/>
+          <a:p>
+            <a:pPr algn="ctr"/>
+          </a:p>
+        </p:txBody>
+      </p:sp>
+      <p:sp>
+        <p:nvSpPr>
+          <p:cNvPr id="52" name="TextBox 51"/>
           <p:cNvSpPr txBox="1"/>
           <p:nvPr/>
         </p:nvSpPr>
         <p:spPr>
           <a:xfrm>
-            <a:off x="256032" y="4443984"/>
-            <a:ext cx="841248" cy="585216"/>
+            <a:off x="4821936" y="3950208"/>
+            <a:ext cx="3377184" cy="182880"/>
+          </a:xfrm>
+          <a:prstGeom prst="rect">
+            <a:avLst/>
+          </a:prstGeom>
+          <a:noFill/>
+        </p:spPr>
+        <p:txBody>
+          <a:bodyPr wrap="square" lIns="0" rIns="0" tIns="0" bIns="0" anchor="ctr"/>
+          <a:lstStyle/>
+          <a:p>
+            <a:pPr algn="l">
+              <a:spcBef>
+                <a:spcPts val="0"/>
+              </a:spcBef>
+              <a:spcAft>
+                <a:spcPts val="0"/>
+              </a:spcAft>
+            </a:pPr>
+            <a:r>
+              <a:rPr sz="1300" b="1">
+                <a:solidFill>
+                  <a:srgbClr val="FFFFFF"/>
+                </a:solidFill>
+                <a:latin typeface="Microsoft YaHei"/>
+                <a:ea typeface="Microsoft YaHei"/>
+                <a:cs typeface="Microsoft YaHei"/>
+              </a:rPr>
+              <a:t>传输  HIXL</a:t>
+            </a:r>
+          </a:p>
+        </p:txBody>
+      </p:sp>
+      <p:sp>
+        <p:nvSpPr>
+          <p:cNvPr id="53" name="TextBox 52"/>
+          <p:cNvSpPr txBox="1"/>
+          <p:nvPr/>
+        </p:nvSpPr>
+        <p:spPr>
+          <a:xfrm>
+            <a:off x="4821936" y="4133088"/>
+            <a:ext cx="3377184" cy="201168"/>
+          </a:xfrm>
+          <a:prstGeom prst="rect">
+            <a:avLst/>
+          </a:prstGeom>
+          <a:noFill/>
+        </p:spPr>
+        <p:txBody>
+          <a:bodyPr wrap="square" lIns="0" rIns="0" tIns="0" bIns="0" anchor="ctr"/>
+          <a:lstStyle/>
+          <a:p>
+            <a:pPr algn="l">
+              <a:spcBef>
+                <a:spcPts val="0"/>
+              </a:spcBef>
+              <a:spcAft>
+                <a:spcPts val="0"/>
+              </a:spcAft>
+            </a:pPr>
+            <a:r>
+              <a:rPr sz="1100" b="0">
+                <a:solidFill>
+                  <a:srgbClr val="FFFFFF"/>
+                </a:solidFill>
+                <a:latin typeface="Microsoft YaHei"/>
+                <a:ea typeface="Microsoft YaHei"/>
+                <a:cs typeface="Microsoft YaHei"/>
+              </a:rPr>
+              <a:t>ascend_direct。DataDist 拉推 KV。</a:t>
+            </a:r>
+          </a:p>
+        </p:txBody>
+      </p:sp>
+      <p:sp>
+        <p:nvSpPr>
+          <p:cNvPr id="54" name="Rectangle 53"/>
+          <p:cNvSpPr/>
+          <p:nvPr/>
+        </p:nvSpPr>
+        <p:spPr>
+          <a:xfrm>
+            <a:off x="8363712" y="3401568"/>
+            <a:ext cx="3523488" cy="384048"/>
+          </a:xfrm>
+          <a:prstGeom prst="rect">
+            <a:avLst/>
+          </a:prstGeom>
+          <a:solidFill>
+            <a:srgbClr val="7A541C"/>
+          </a:solidFill>
+          <a:ln>
+            <a:noFill/>
+          </a:ln>
+        </p:spPr>
+        <p:style>
+          <a:lnRef idx="1">
+            <a:schemeClr val="accent1"/>
+          </a:lnRef>
+          <a:fillRef idx="3">
+            <a:schemeClr val="accent1"/>
+          </a:fillRef>
+          <a:effectRef idx="2">
+            <a:schemeClr val="accent1"/>
+          </a:effectRef>
+          <a:fontRef idx="minor">
+            <a:schemeClr val="lt1"/>
+          </a:fontRef>
+        </p:style>
+        <p:txBody>
+          <a:bodyPr rtlCol="0" anchor="ctr"/>
+          <a:lstStyle/>
+          <a:p>
+            <a:pPr algn="ctr"/>
+          </a:p>
+        </p:txBody>
+      </p:sp>
+      <p:sp>
+        <p:nvSpPr>
+          <p:cNvPr id="55" name="TextBox 54"/>
+          <p:cNvSpPr txBox="1"/>
+          <p:nvPr/>
+        </p:nvSpPr>
+        <p:spPr>
+          <a:xfrm>
+            <a:off x="8436864" y="3410712"/>
+            <a:ext cx="3377184" cy="182880"/>
+          </a:xfrm>
+          <a:prstGeom prst="rect">
+            <a:avLst/>
+          </a:prstGeom>
+          <a:noFill/>
+        </p:spPr>
+        <p:txBody>
+          <a:bodyPr wrap="square" lIns="0" rIns="0" tIns="0" bIns="0" anchor="ctr"/>
+          <a:lstStyle/>
+          <a:p>
+            <a:pPr algn="l">
+              <a:spcBef>
+                <a:spcPts val="0"/>
+              </a:spcBef>
+              <a:spcAft>
+                <a:spcPts val="0"/>
+              </a:spcAft>
+            </a:pPr>
+            <a:r>
+              <a:rPr sz="1300" b="1">
+                <a:solidFill>
+                  <a:srgbClr val="FFFFFF"/>
+                </a:solidFill>
+                <a:latin typeface="Microsoft YaHei"/>
+                <a:ea typeface="Microsoft YaHei"/>
+                <a:cs typeface="Microsoft YaHei"/>
+              </a:rPr>
+              <a:t>池  YuanRong</a:t>
+            </a:r>
+          </a:p>
+        </p:txBody>
+      </p:sp>
+      <p:sp>
+        <p:nvSpPr>
+          <p:cNvPr id="56" name="TextBox 55"/>
+          <p:cNvSpPr txBox="1"/>
+          <p:nvPr/>
+        </p:nvSpPr>
+        <p:spPr>
+          <a:xfrm>
+            <a:off x="8436864" y="3593592"/>
+            <a:ext cx="3377184" cy="182880"/>
+          </a:xfrm>
+          <a:prstGeom prst="rect">
+            <a:avLst/>
+          </a:prstGeom>
+          <a:noFill/>
+        </p:spPr>
+        <p:txBody>
+          <a:bodyPr wrap="square" lIns="0" rIns="0" tIns="0" bIns="0" anchor="ctr"/>
+          <a:lstStyle/>
+          <a:p>
+            <a:pPr algn="l">
+              <a:spcBef>
+                <a:spcPts val="0"/>
+              </a:spcBef>
+              <a:spcAft>
+                <a:spcPts val="0"/>
+              </a:spcAft>
+            </a:pPr>
+            <a:r>
+              <a:rPr sz="1100" b="0">
+                <a:solidFill>
+                  <a:srgbClr val="FFFFFF"/>
+                </a:solidFill>
+                <a:latin typeface="Microsoft YaHei"/>
+                <a:ea typeface="Microsoft YaHei"/>
+                <a:cs typeface="Microsoft YaHei"/>
+              </a:rPr>
+              <a:t>第三种 backend。</a:t>
+            </a:r>
+          </a:p>
+        </p:txBody>
+      </p:sp>
+      <p:sp>
+        <p:nvSpPr>
+          <p:cNvPr id="57" name="Down Arrow 56"/>
+          <p:cNvSpPr/>
+          <p:nvPr/>
+        </p:nvSpPr>
+        <p:spPr>
+          <a:xfrm>
+            <a:off x="10043160" y="3785616"/>
+            <a:ext cx="164592" cy="146304"/>
+          </a:xfrm>
+          <a:prstGeom prst="downArrow">
+            <a:avLst/>
+          </a:prstGeom>
+          <a:solidFill>
+            <a:srgbClr val="2E4A6E"/>
+          </a:solidFill>
+          <a:ln>
+            <a:noFill/>
+          </a:ln>
+        </p:spPr>
+        <p:style>
+          <a:lnRef idx="1">
+            <a:schemeClr val="accent1"/>
+          </a:lnRef>
+          <a:fillRef idx="3">
+            <a:schemeClr val="accent1"/>
+          </a:fillRef>
+          <a:effectRef idx="2">
+            <a:schemeClr val="accent1"/>
+          </a:effectRef>
+          <a:fontRef idx="minor">
+            <a:schemeClr val="lt1"/>
+          </a:fontRef>
+        </p:style>
+        <p:txBody>
+          <a:bodyPr rtlCol="0" anchor="ctr"/>
+          <a:lstStyle/>
+          <a:p>
+            <a:pPr algn="ctr"/>
+          </a:p>
+        </p:txBody>
+      </p:sp>
+      <p:sp>
+        <p:nvSpPr>
+          <p:cNvPr id="58" name="Rectangle 57"/>
+          <p:cNvSpPr/>
+          <p:nvPr/>
+        </p:nvSpPr>
+        <p:spPr>
+          <a:xfrm>
+            <a:off x="8363712" y="3931920"/>
+            <a:ext cx="3523488" cy="420624"/>
+          </a:xfrm>
+          <a:prstGeom prst="rect">
+            <a:avLst/>
+          </a:prstGeom>
+          <a:solidFill>
+            <a:srgbClr val="2E4A6E"/>
+          </a:solidFill>
+          <a:ln>
+            <a:noFill/>
+          </a:ln>
+        </p:spPr>
+        <p:style>
+          <a:lnRef idx="1">
+            <a:schemeClr val="accent1"/>
+          </a:lnRef>
+          <a:fillRef idx="3">
+            <a:schemeClr val="accent1"/>
+          </a:fillRef>
+          <a:effectRef idx="2">
+            <a:schemeClr val="accent1"/>
+          </a:effectRef>
+          <a:fontRef idx="minor">
+            <a:schemeClr val="lt1"/>
+          </a:fontRef>
+        </p:style>
+        <p:txBody>
+          <a:bodyPr rtlCol="0" anchor="ctr"/>
+          <a:lstStyle/>
+          <a:p>
+            <a:pPr algn="ctr"/>
+          </a:p>
+        </p:txBody>
+      </p:sp>
+      <p:sp>
+        <p:nvSpPr>
+          <p:cNvPr id="59" name="TextBox 58"/>
+          <p:cNvSpPr txBox="1"/>
+          <p:nvPr/>
+        </p:nvSpPr>
+        <p:spPr>
+          <a:xfrm>
+            <a:off x="8436864" y="3950208"/>
+            <a:ext cx="3377184" cy="182880"/>
+          </a:xfrm>
+          <a:prstGeom prst="rect">
+            <a:avLst/>
+          </a:prstGeom>
+          <a:noFill/>
+        </p:spPr>
+        <p:txBody>
+          <a:bodyPr wrap="square" lIns="0" rIns="0" tIns="0" bIns="0" anchor="ctr"/>
+          <a:lstStyle/>
+          <a:p>
+            <a:pPr algn="l">
+              <a:spcBef>
+                <a:spcPts val="0"/>
+              </a:spcBef>
+              <a:spcAft>
+                <a:spcPts val="0"/>
+              </a:spcAft>
+            </a:pPr>
+            <a:r>
+              <a:rPr sz="1300" b="1">
+                <a:solidFill>
+                  <a:srgbClr val="FFFFFF"/>
+                </a:solidFill>
+                <a:latin typeface="Microsoft YaHei"/>
+                <a:ea typeface="Microsoft YaHei"/>
+                <a:cs typeface="Microsoft YaHei"/>
+              </a:rPr>
+              <a:t>传输  随该后端</a:t>
+            </a:r>
+          </a:p>
+        </p:txBody>
+      </p:sp>
+      <p:sp>
+        <p:nvSpPr>
+          <p:cNvPr id="60" name="TextBox 59"/>
+          <p:cNvSpPr txBox="1"/>
+          <p:nvPr/>
+        </p:nvSpPr>
+        <p:spPr>
+          <a:xfrm>
+            <a:off x="8436864" y="4133088"/>
+            <a:ext cx="3377184" cy="201168"/>
+          </a:xfrm>
+          <a:prstGeom prst="rect">
+            <a:avLst/>
+          </a:prstGeom>
+          <a:noFill/>
+        </p:spPr>
+        <p:txBody>
+          <a:bodyPr wrap="square" lIns="0" rIns="0" tIns="0" bIns="0" anchor="ctr"/>
+          <a:lstStyle/>
+          <a:p>
+            <a:pPr algn="l">
+              <a:spcBef>
+                <a:spcPts val="0"/>
+              </a:spcBef>
+              <a:spcAft>
+                <a:spcPts val="0"/>
+              </a:spcAft>
+            </a:pPr>
+            <a:r>
+              <a:rPr sz="1100" b="0">
+                <a:solidFill>
+                  <a:srgbClr val="FFFFFF"/>
+                </a:solidFill>
+                <a:latin typeface="Microsoft YaHei"/>
+                <a:ea typeface="Microsoft YaHei"/>
+                <a:cs typeface="Microsoft YaHei"/>
+              </a:rPr>
+              <a:t>由 AscendStoreConnector 选定。</a:t>
+            </a:r>
+          </a:p>
+        </p:txBody>
+      </p:sp>
+      <p:sp>
+        <p:nvSpPr>
+          <p:cNvPr id="61" name="TextBox 60"/>
+          <p:cNvSpPr txBox="1"/>
+          <p:nvPr/>
+        </p:nvSpPr>
+        <p:spPr>
+          <a:xfrm>
+            <a:off x="256032" y="4425696"/>
+            <a:ext cx="841248" cy="292608"/>
           </a:xfrm>
           <a:prstGeom prst="rect">
             <a:avLst/>
@@ -5747,21 +6257,21 @@
                 <a:ea typeface="Microsoft YaHei"/>
                 <a:cs typeface="Microsoft YaHei"/>
               </a:rPr>
-              <a:t>通信</a:t>
-            </a:r>
-          </a:p>
-        </p:txBody>
-      </p:sp>
-      <p:sp>
-        <p:nvSpPr>
-          <p:cNvPr id="50" name="Rectangle 49"/>
+              <a:t>集合</a:t>
+            </a:r>
+          </a:p>
+        </p:txBody>
+      </p:sp>
+      <p:sp>
+        <p:nvSpPr>
+          <p:cNvPr id="62" name="Rectangle 61"/>
           <p:cNvSpPr/>
           <p:nvPr/>
         </p:nvSpPr>
         <p:spPr>
           <a:xfrm>
-            <a:off x="1133856" y="4443984"/>
-            <a:ext cx="2633472" cy="585216"/>
+            <a:off x="1133856" y="4425696"/>
+            <a:ext cx="1554480" cy="292608"/>
           </a:xfrm>
           <a:prstGeom prst="rect">
             <a:avLst/>
@@ -5788,34 +6298,10 @@
           </a:fontRef>
         </p:style>
         <p:txBody>
-          <a:bodyPr rtlCol="0" anchor="ctr"/>
-          <a:lstStyle/>
-          <a:p>
-            <a:pPr algn="ctr"/>
-          </a:p>
-        </p:txBody>
-      </p:sp>
-      <p:sp>
-        <p:nvSpPr>
-          <p:cNvPr id="51" name="TextBox 50"/>
-          <p:cNvSpPr txBox="1"/>
-          <p:nvPr/>
-        </p:nvSpPr>
-        <p:spPr>
-          <a:xfrm>
-            <a:off x="1207008" y="4480560"/>
-            <a:ext cx="2487168" cy="219456"/>
-          </a:xfrm>
-          <a:prstGeom prst="rect">
-            <a:avLst/>
-          </a:prstGeom>
-          <a:noFill/>
-        </p:spPr>
-        <p:txBody>
-          <a:bodyPr wrap="square" lIns="0" rIns="0" tIns="0" bIns="0" anchor="ctr"/>
-          <a:lstStyle/>
-          <a:p>
-            <a:pPr algn="l">
+          <a:bodyPr rtlCol="0" anchor="ctr" wrap="square" lIns="54864" rIns="54864" tIns="18288" bIns="18288"/>
+          <a:lstStyle/>
+          <a:p>
+            <a:pPr algn="ctr">
               <a:spcBef>
                 <a:spcPts val="0"/>
               </a:spcBef>
@@ -5839,14 +6325,57 @@
       </p:sp>
       <p:sp>
         <p:nvSpPr>
-          <p:cNvPr id="52" name="TextBox 51"/>
+          <p:cNvPr id="63" name="Rectangle 62"/>
+          <p:cNvSpPr/>
+          <p:nvPr/>
+        </p:nvSpPr>
+        <p:spPr>
+          <a:xfrm>
+            <a:off x="2688336" y="4425696"/>
+            <a:ext cx="9198864" cy="292608"/>
+          </a:xfrm>
+          <a:prstGeom prst="rect">
+            <a:avLst/>
+          </a:prstGeom>
+          <a:solidFill>
+            <a:srgbClr val="145A96"/>
+          </a:solidFill>
+          <a:ln>
+            <a:noFill/>
+          </a:ln>
+        </p:spPr>
+        <p:style>
+          <a:lnRef idx="1">
+            <a:schemeClr val="accent1"/>
+          </a:lnRef>
+          <a:fillRef idx="3">
+            <a:schemeClr val="accent1"/>
+          </a:fillRef>
+          <a:effectRef idx="2">
+            <a:schemeClr val="accent1"/>
+          </a:effectRef>
+          <a:fontRef idx="minor">
+            <a:schemeClr val="lt1"/>
+          </a:fontRef>
+        </p:style>
+        <p:txBody>
+          <a:bodyPr rtlCol="0" anchor="ctr"/>
+          <a:lstStyle/>
+          <a:p>
+            <a:pPr algn="ctr"/>
+          </a:p>
+        </p:txBody>
+      </p:sp>
+      <p:sp>
+        <p:nvSpPr>
+          <p:cNvPr id="64" name="TextBox 63"/>
           <p:cNvSpPr txBox="1"/>
           <p:nvPr/>
         </p:nvSpPr>
         <p:spPr>
           <a:xfrm>
-            <a:off x="1207008" y="4700016"/>
-            <a:ext cx="2487168" cy="292608"/>
+            <a:off x="2798064" y="4425696"/>
+            <a:ext cx="9015984" cy="292608"/>
           </a:xfrm>
           <a:prstGeom prst="rect">
             <a:avLst/>
@@ -5854,7 +6383,7 @@
           <a:noFill/>
         </p:spPr>
         <p:txBody>
-          <a:bodyPr wrap="square" lIns="0" rIns="0" tIns="0" bIns="0" anchor="t"/>
+          <a:bodyPr wrap="square" lIns="0" rIns="0" tIns="0" bIns="0" anchor="ctr"/>
           <a:lstStyle/>
           <a:p>
             <a:pPr algn="l">
@@ -5866,7 +6395,7 @@
               </a:spcAft>
             </a:pPr>
             <a:r>
-              <a:rPr sz="1100" b="0">
+              <a:rPr sz="1300" b="0">
                 <a:solidFill>
                   <a:srgbClr val="FFFFFF"/>
                 </a:solidFill>
@@ -5874,30 +6403,74 @@
                 <a:ea typeface="Microsoft YaHei"/>
                 <a:cs typeface="Microsoft YaHei"/>
               </a:rPr>
-              <a:t>集合通信。服务张量并行和专家并行。</a:t>
-            </a:r>
-          </a:p>
-        </p:txBody>
-      </p:sp>
-      <p:sp>
-        <p:nvSpPr>
-          <p:cNvPr id="53" name="Rectangle 52"/>
+              <a:t>基础库是 HCOMM。服务张量并行与专家并行。</a:t>
+            </a:r>
+          </a:p>
+        </p:txBody>
+      </p:sp>
+      <p:sp>
+        <p:nvSpPr>
+          <p:cNvPr id="65" name="TextBox 64"/>
+          <p:cNvSpPr txBox="1"/>
+          <p:nvPr/>
+        </p:nvSpPr>
+        <p:spPr>
+          <a:xfrm>
+            <a:off x="256032" y="4773168"/>
+            <a:ext cx="841248" cy="402336"/>
+          </a:xfrm>
+          <a:prstGeom prst="rect">
+            <a:avLst/>
+          </a:prstGeom>
+          <a:noFill/>
+        </p:spPr>
+        <p:txBody>
+          <a:bodyPr wrap="square" lIns="0" rIns="0" tIns="0" bIns="0" anchor="ctr"/>
+          <a:lstStyle/>
+          <a:p>
+            <a:pPr algn="l">
+              <a:spcBef>
+                <a:spcPts val="0"/>
+              </a:spcBef>
+              <a:spcAft>
+                <a:spcPts val="0"/>
+              </a:spcAft>
+            </a:pPr>
+            <a:r>
+              <a:rPr sz="1200" b="1">
+                <a:solidFill>
+                  <a:srgbClr val="0E2A47"/>
+                </a:solidFill>
+                <a:latin typeface="Microsoft YaHei"/>
+                <a:ea typeface="Microsoft YaHei"/>
+                <a:cs typeface="Microsoft YaHei"/>
+              </a:rPr>
+              <a:t>算子</a:t>
+            </a:r>
+          </a:p>
+        </p:txBody>
+      </p:sp>
+      <p:sp>
+        <p:nvSpPr>
+          <p:cNvPr id="66" name="Rectangle 65"/>
           <p:cNvSpPr/>
           <p:nvPr/>
         </p:nvSpPr>
         <p:spPr>
           <a:xfrm>
-            <a:off x="3840480" y="4443984"/>
-            <a:ext cx="2633472" cy="585216"/>
+            <a:off x="1133856" y="4773168"/>
+            <a:ext cx="10753344" cy="402336"/>
           </a:xfrm>
           <a:prstGeom prst="rect">
             <a:avLst/>
           </a:prstGeom>
           <a:solidFill>
-            <a:srgbClr val="2E4A6E"/>
+            <a:srgbClr val="FFFFFF"/>
           </a:solidFill>
-          <a:ln>
-            <a:noFill/>
+          <a:ln w="9525">
+            <a:solidFill>
+              <a:srgbClr val="D6DCE2"/>
+            </a:solidFill>
           </a:ln>
         </p:spPr>
         <p:style>
@@ -5924,225 +6497,14 @@
       </p:sp>
       <p:sp>
         <p:nvSpPr>
-          <p:cNvPr id="54" name="TextBox 53"/>
-          <p:cNvSpPr txBox="1"/>
-          <p:nvPr/>
-        </p:nvSpPr>
-        <p:spPr>
-          <a:xfrm>
-            <a:off x="3913632" y="4480560"/>
-            <a:ext cx="2487168" cy="219456"/>
-          </a:xfrm>
-          <a:prstGeom prst="rect">
-            <a:avLst/>
-          </a:prstGeom>
-          <a:noFill/>
-        </p:spPr>
-        <p:txBody>
-          <a:bodyPr wrap="square" lIns="0" rIns="0" tIns="0" bIns="0" anchor="ctr"/>
-          <a:lstStyle/>
-          <a:p>
-            <a:pPr algn="l">
-              <a:spcBef>
-                <a:spcPts val="0"/>
-              </a:spcBef>
-              <a:spcAft>
-                <a:spcPts val="0"/>
-              </a:spcAft>
-            </a:pPr>
-            <a:r>
-              <a:rPr sz="1300" b="1">
-                <a:solidFill>
-                  <a:srgbClr val="FFFFFF"/>
-                </a:solidFill>
-                <a:latin typeface="Microsoft YaHei"/>
-                <a:ea typeface="Microsoft YaHei"/>
-                <a:cs typeface="Microsoft YaHei"/>
-              </a:rPr>
-              <a:t>HCOMM</a:t>
-            </a:r>
-          </a:p>
-        </p:txBody>
-      </p:sp>
-      <p:sp>
-        <p:nvSpPr>
-          <p:cNvPr id="55" name="TextBox 54"/>
-          <p:cNvSpPr txBox="1"/>
-          <p:nvPr/>
-        </p:nvSpPr>
-        <p:spPr>
-          <a:xfrm>
-            <a:off x="3913632" y="4700016"/>
-            <a:ext cx="2487168" cy="292608"/>
-          </a:xfrm>
-          <a:prstGeom prst="rect">
-            <a:avLst/>
-          </a:prstGeom>
-          <a:noFill/>
-        </p:spPr>
-        <p:txBody>
-          <a:bodyPr wrap="square" lIns="0" rIns="0" tIns="0" bIns="0" anchor="t"/>
-          <a:lstStyle/>
-          <a:p>
-            <a:pPr algn="l">
-              <a:spcBef>
-                <a:spcPts val="0"/>
-              </a:spcBef>
-              <a:spcAft>
-                <a:spcPts val="0"/>
-              </a:spcAft>
-            </a:pPr>
-            <a:r>
-              <a:rPr sz="1100" b="0">
-                <a:solidFill>
-                  <a:srgbClr val="FFFFFF"/>
-                </a:solidFill>
-                <a:latin typeface="Microsoft YaHei"/>
-                <a:ea typeface="Microsoft YaHei"/>
-                <a:cs typeface="Microsoft YaHei"/>
-              </a:rPr>
-              <a:t>HCCL 的基础库。控制面与数据面。</a:t>
-            </a:r>
-          </a:p>
-        </p:txBody>
-      </p:sp>
-      <p:sp>
-        <p:nvSpPr>
-          <p:cNvPr id="56" name="Rectangle 55"/>
+          <p:cNvPr id="67" name="Rectangle 66"/>
           <p:cNvSpPr/>
           <p:nvPr/>
         </p:nvSpPr>
         <p:spPr>
           <a:xfrm>
-            <a:off x="6547104" y="4443984"/>
-            <a:ext cx="2633472" cy="585216"/>
-          </a:xfrm>
-          <a:prstGeom prst="rect">
-            <a:avLst/>
-          </a:prstGeom>
-          <a:solidFill>
-            <a:srgbClr val="0E7A76"/>
-          </a:solidFill>
-          <a:ln>
-            <a:noFill/>
-          </a:ln>
-        </p:spPr>
-        <p:style>
-          <a:lnRef idx="1">
-            <a:schemeClr val="accent1"/>
-          </a:lnRef>
-          <a:fillRef idx="3">
-            <a:schemeClr val="accent1"/>
-          </a:fillRef>
-          <a:effectRef idx="2">
-            <a:schemeClr val="accent1"/>
-          </a:effectRef>
-          <a:fontRef idx="minor">
-            <a:schemeClr val="lt1"/>
-          </a:fontRef>
-        </p:style>
-        <p:txBody>
-          <a:bodyPr rtlCol="0" anchor="ctr"/>
-          <a:lstStyle/>
-          <a:p>
-            <a:pPr algn="ctr"/>
-          </a:p>
-        </p:txBody>
-      </p:sp>
-      <p:sp>
-        <p:nvSpPr>
-          <p:cNvPr id="57" name="TextBox 56"/>
-          <p:cNvSpPr txBox="1"/>
-          <p:nvPr/>
-        </p:nvSpPr>
-        <p:spPr>
-          <a:xfrm>
-            <a:off x="6620256" y="4480560"/>
-            <a:ext cx="2487168" cy="219456"/>
-          </a:xfrm>
-          <a:prstGeom prst="rect">
-            <a:avLst/>
-          </a:prstGeom>
-          <a:noFill/>
-        </p:spPr>
-        <p:txBody>
-          <a:bodyPr wrap="square" lIns="0" rIns="0" tIns="0" bIns="0" anchor="ctr"/>
-          <a:lstStyle/>
-          <a:p>
-            <a:pPr algn="l">
-              <a:spcBef>
-                <a:spcPts val="0"/>
-              </a:spcBef>
-              <a:spcAft>
-                <a:spcPts val="0"/>
-              </a:spcAft>
-            </a:pPr>
-            <a:r>
-              <a:rPr sz="1300" b="1">
-                <a:solidFill>
-                  <a:srgbClr val="FFFFFF"/>
-                </a:solidFill>
-                <a:latin typeface="Microsoft YaHei"/>
-                <a:ea typeface="Microsoft YaHei"/>
-                <a:cs typeface="Microsoft YaHei"/>
-              </a:rPr>
-              <a:t>HIXL</a:t>
-            </a:r>
-          </a:p>
-        </p:txBody>
-      </p:sp>
-      <p:sp>
-        <p:nvSpPr>
-          <p:cNvPr id="58" name="TextBox 57"/>
-          <p:cNvSpPr txBox="1"/>
-          <p:nvPr/>
-        </p:nvSpPr>
-        <p:spPr>
-          <a:xfrm>
-            <a:off x="6620256" y="4700016"/>
-            <a:ext cx="2487168" cy="292608"/>
-          </a:xfrm>
-          <a:prstGeom prst="rect">
-            <a:avLst/>
-          </a:prstGeom>
-          <a:noFill/>
-        </p:spPr>
-        <p:txBody>
-          <a:bodyPr wrap="square" lIns="0" rIns="0" tIns="0" bIns="0" anchor="t"/>
-          <a:lstStyle/>
-          <a:p>
-            <a:pPr algn="l">
-              <a:spcBef>
-                <a:spcPts val="0"/>
-              </a:spcBef>
-              <a:spcAft>
-                <a:spcPts val="0"/>
-              </a:spcAft>
-            </a:pPr>
-            <a:r>
-              <a:rPr sz="1100" b="0">
-                <a:solidFill>
-                  <a:srgbClr val="FFFFFF"/>
-                </a:solidFill>
-                <a:latin typeface="Microsoft YaHei"/>
-                <a:ea typeface="Microsoft YaHei"/>
-                <a:cs typeface="Microsoft YaHei"/>
-              </a:rPr>
-              <a:t>单边。LLM-DataDist 拉取和推送 KV。</a:t>
-            </a:r>
-          </a:p>
-        </p:txBody>
-      </p:sp>
-      <p:sp>
-        <p:nvSpPr>
-          <p:cNvPr id="59" name="Rectangle 58"/>
-          <p:cNvSpPr/>
-          <p:nvPr/>
-        </p:nvSpPr>
-        <p:spPr>
-          <a:xfrm>
-            <a:off x="9253728" y="4443984"/>
-            <a:ext cx="2633472" cy="585216"/>
+            <a:off x="1133856" y="4773168"/>
+            <a:ext cx="1554480" cy="402336"/>
           </a:xfrm>
           <a:prstGeom prst="rect">
             <a:avLst/>
@@ -6169,34 +6531,10 @@
           </a:fontRef>
         </p:style>
         <p:txBody>
-          <a:bodyPr rtlCol="0" anchor="ctr"/>
-          <a:lstStyle/>
-          <a:p>
-            <a:pPr algn="ctr"/>
-          </a:p>
-        </p:txBody>
-      </p:sp>
-      <p:sp>
-        <p:nvSpPr>
-          <p:cNvPr id="60" name="TextBox 59"/>
-          <p:cNvSpPr txBox="1"/>
-          <p:nvPr/>
-        </p:nvSpPr>
-        <p:spPr>
-          <a:xfrm>
-            <a:off x="9326880" y="4480560"/>
-            <a:ext cx="2487168" cy="219456"/>
-          </a:xfrm>
-          <a:prstGeom prst="rect">
-            <a:avLst/>
-          </a:prstGeom>
-          <a:noFill/>
-        </p:spPr>
-        <p:txBody>
-          <a:bodyPr wrap="square" lIns="0" rIns="0" tIns="0" bIns="0" anchor="ctr"/>
-          <a:lstStyle/>
-          <a:p>
-            <a:pPr algn="l">
+          <a:bodyPr rtlCol="0" anchor="ctr" wrap="square" lIns="54864" rIns="54864" tIns="18288" bIns="18288"/>
+          <a:lstStyle/>
+          <a:p>
+            <a:pPr algn="ctr">
               <a:spcBef>
                 <a:spcPts val="0"/>
               </a:spcBef>
@@ -6220,14 +6558,14 @@
       </p:sp>
       <p:sp>
         <p:nvSpPr>
-          <p:cNvPr id="61" name="TextBox 60"/>
+          <p:cNvPr id="68" name="TextBox 67"/>
           <p:cNvSpPr txBox="1"/>
           <p:nvPr/>
         </p:nvSpPr>
         <p:spPr>
           <a:xfrm>
-            <a:off x="9326880" y="4700016"/>
-            <a:ext cx="2487168" cy="292608"/>
+            <a:off x="2798064" y="4773168"/>
+            <a:ext cx="8961120" cy="402336"/>
           </a:xfrm>
           <a:prstGeom prst="rect">
             <a:avLst/>
@@ -6235,7 +6573,7 @@
           <a:noFill/>
         </p:spPr>
         <p:txBody>
-          <a:bodyPr wrap="square" lIns="0" rIns="0" tIns="0" bIns="0" anchor="t"/>
+          <a:bodyPr wrap="square" lIns="0" rIns="0" tIns="0" bIns="0" anchor="ctr"/>
           <a:lstStyle/>
           <a:p>
             <a:pPr algn="l">
@@ -6247,29 +6585,29 @@
               </a:spcAft>
             </a:pPr>
             <a:r>
-              <a:rPr sz="1100" b="0">
+              <a:rPr sz="1300" b="0">
                 <a:solidFill>
-                  <a:srgbClr val="FFFFFF"/>
+                  <a:srgbClr val="1C242E"/>
                 </a:solidFill>
                 <a:latin typeface="Microsoft YaHei"/>
                 <a:ea typeface="Microsoft YaHei"/>
                 <a:cs typeface="Microsoft YaHei"/>
               </a:rPr>
-              <a:t>对称内存。卡间单边访问，给定制算子。</a:t>
-            </a:r>
-          </a:p>
-        </p:txBody>
-      </p:sp>
-      <p:sp>
-        <p:nvSpPr>
-          <p:cNvPr id="62" name="TextBox 61"/>
+              <a:t>对称内存，给定制算子。默认的 MindIE / vLLM-Ascend 推理不调用。kv_shuffle 只是示例。</a:t>
+            </a:r>
+          </a:p>
+        </p:txBody>
+      </p:sp>
+      <p:sp>
+        <p:nvSpPr>
+          <p:cNvPr id="69" name="TextBox 68"/>
           <p:cNvSpPr txBox="1"/>
           <p:nvPr/>
         </p:nvSpPr>
         <p:spPr>
           <a:xfrm>
-            <a:off x="256032" y="5120640"/>
-            <a:ext cx="841248" cy="365760"/>
+            <a:off x="256032" y="5248656"/>
+            <a:ext cx="841248" cy="256032"/>
           </a:xfrm>
           <a:prstGeom prst="rect">
             <a:avLst/>
@@ -6289,7 +6627,7 @@
               </a:spcAft>
             </a:pPr>
             <a:r>
-              <a:rPr sz="1300" b="1">
+              <a:rPr sz="1200" b="1">
                 <a:solidFill>
                   <a:srgbClr val="145A96"/>
                 </a:solidFill>
@@ -6304,14 +6642,14 @@
       </p:sp>
       <p:sp>
         <p:nvSpPr>
-          <p:cNvPr id="63" name="Rectangle 62"/>
+          <p:cNvPr id="70" name="Rectangle 69"/>
           <p:cNvSpPr/>
           <p:nvPr/>
         </p:nvSpPr>
         <p:spPr>
           <a:xfrm>
-            <a:off x="1133856" y="5120640"/>
-            <a:ext cx="1554480" cy="365760"/>
+            <a:off x="1133856" y="5248656"/>
+            <a:ext cx="1554480" cy="256032"/>
           </a:xfrm>
           <a:prstGeom prst="rect">
             <a:avLst/>
@@ -6365,14 +6703,14 @@
       </p:sp>
       <p:sp>
         <p:nvSpPr>
-          <p:cNvPr id="64" name="Rectangle 63"/>
+          <p:cNvPr id="71" name="Rectangle 70"/>
           <p:cNvSpPr/>
           <p:nvPr/>
         </p:nvSpPr>
         <p:spPr>
           <a:xfrm>
-            <a:off x="2688336" y="5120640"/>
-            <a:ext cx="9198864" cy="365760"/>
+            <a:off x="2688336" y="5248656"/>
+            <a:ext cx="9198864" cy="256032"/>
           </a:xfrm>
           <a:prstGeom prst="rect">
             <a:avLst/>
@@ -6408,14 +6746,14 @@
       </p:sp>
       <p:sp>
         <p:nvSpPr>
-          <p:cNvPr id="65" name="TextBox 64"/>
+          <p:cNvPr id="72" name="TextBox 71"/>
           <p:cNvSpPr txBox="1"/>
           <p:nvPr/>
         </p:nvSpPr>
         <p:spPr>
           <a:xfrm>
-            <a:off x="2798064" y="5120640"/>
-            <a:ext cx="9015984" cy="365760"/>
+            <a:off x="2798064" y="5248656"/>
+            <a:ext cx="9015984" cy="256032"/>
           </a:xfrm>
           <a:prstGeom prst="rect">
             <a:avLst/>
@@ -6443,21 +6781,21 @@
                 <a:ea typeface="Microsoft YaHei"/>
                 <a:cs typeface="Microsoft YaHei"/>
               </a:rPr>
-              <a:t>AscendCL、GE、Runtime、算子库、DVPP。通信四库也在这一层。推理包是 NNRT。</a:t>
-            </a:r>
-          </a:p>
-        </p:txBody>
-      </p:sp>
-      <p:sp>
-        <p:nvSpPr>
-          <p:cNvPr id="66" name="TextBox 65"/>
+              <a:t>AscendCL、GE、Runtime、算子库、DVPP。推理包是 NNRT。</a:t>
+            </a:r>
+          </a:p>
+        </p:txBody>
+      </p:sp>
+      <p:sp>
+        <p:nvSpPr>
+          <p:cNvPr id="73" name="TextBox 72"/>
           <p:cNvSpPr txBox="1"/>
           <p:nvPr/>
         </p:nvSpPr>
         <p:spPr>
           <a:xfrm>
             <a:off x="256032" y="5541264"/>
-            <a:ext cx="841248" cy="274320"/>
+            <a:ext cx="841248" cy="237744"/>
           </a:xfrm>
           <a:prstGeom prst="rect">
             <a:avLst/>
@@ -6477,7 +6815,7 @@
               </a:spcAft>
             </a:pPr>
             <a:r>
-              <a:rPr sz="1300" b="1">
+              <a:rPr sz="1200" b="1">
                 <a:solidFill>
                   <a:srgbClr val="2E4A6E"/>
                 </a:solidFill>
@@ -6492,14 +6830,14 @@
       </p:sp>
       <p:sp>
         <p:nvSpPr>
-          <p:cNvPr id="67" name="Rectangle 66"/>
+          <p:cNvPr id="74" name="Rectangle 73"/>
           <p:cNvSpPr/>
           <p:nvPr/>
         </p:nvSpPr>
         <p:spPr>
           <a:xfrm>
             <a:off x="1133856" y="5541264"/>
-            <a:ext cx="1554480" cy="274320"/>
+            <a:ext cx="1554480" cy="237744"/>
           </a:xfrm>
           <a:prstGeom prst="rect">
             <a:avLst/>
@@ -6546,21 +6884,21 @@
                 <a:ea typeface="Microsoft YaHei"/>
                 <a:cs typeface="Microsoft YaHei"/>
               </a:rPr>
-              <a:t>HDK / Driver</a:t>
-            </a:r>
-          </a:p>
-        </p:txBody>
-      </p:sp>
-      <p:sp>
-        <p:nvSpPr>
-          <p:cNvPr id="68" name="Rectangle 67"/>
+              <a:t>HDK</a:t>
+            </a:r>
+          </a:p>
+        </p:txBody>
+      </p:sp>
+      <p:sp>
+        <p:nvSpPr>
+          <p:cNvPr id="75" name="Rectangle 74"/>
           <p:cNvSpPr/>
           <p:nvPr/>
         </p:nvSpPr>
         <p:spPr>
           <a:xfrm>
             <a:off x="2688336" y="5541264"/>
-            <a:ext cx="9198864" cy="274320"/>
+            <a:ext cx="9198864" cy="237744"/>
           </a:xfrm>
           <a:prstGeom prst="rect">
             <a:avLst/>
@@ -6596,14 +6934,14 @@
       </p:sp>
       <p:sp>
         <p:nvSpPr>
-          <p:cNvPr id="69" name="TextBox 68"/>
+          <p:cNvPr id="76" name="TextBox 75"/>
           <p:cNvSpPr txBox="1"/>
           <p:nvPr/>
         </p:nvSpPr>
         <p:spPr>
           <a:xfrm>
             <a:off x="2798064" y="5541264"/>
-            <a:ext cx="9015984" cy="274320"/>
+            <a:ext cx="9015984" cy="237744"/>
           </a:xfrm>
           <a:prstGeom prst="rect">
             <a:avLst/>
@@ -6638,14 +6976,14 @@
       </p:sp>
       <p:sp>
         <p:nvSpPr>
-          <p:cNvPr id="70" name="TextBox 69"/>
+          <p:cNvPr id="77" name="TextBox 76"/>
           <p:cNvSpPr txBox="1"/>
           <p:nvPr/>
         </p:nvSpPr>
         <p:spPr>
           <a:xfrm>
-            <a:off x="256032" y="5870448"/>
-            <a:ext cx="841248" cy="274320"/>
+            <a:off x="256032" y="5815584"/>
+            <a:ext cx="841248" cy="237744"/>
           </a:xfrm>
           <a:prstGeom prst="rect">
             <a:avLst/>
@@ -6665,7 +7003,7 @@
               </a:spcAft>
             </a:pPr>
             <a:r>
-              <a:rPr sz="1300" b="1">
+              <a:rPr sz="1200" b="1">
                 <a:solidFill>
                   <a:srgbClr val="0E2A47"/>
                 </a:solidFill>
@@ -6680,14 +7018,14 @@
       </p:sp>
       <p:sp>
         <p:nvSpPr>
-          <p:cNvPr id="71" name="Rectangle 70"/>
+          <p:cNvPr id="78" name="Rectangle 77"/>
           <p:cNvSpPr/>
           <p:nvPr/>
         </p:nvSpPr>
         <p:spPr>
           <a:xfrm>
-            <a:off x="1133856" y="5870448"/>
-            <a:ext cx="1554480" cy="274320"/>
+            <a:off x="1133856" y="5815584"/>
+            <a:ext cx="1554480" cy="237744"/>
           </a:xfrm>
           <a:prstGeom prst="rect">
             <a:avLst/>
@@ -6734,21 +7072,21 @@
                 <a:ea typeface="Microsoft YaHei"/>
                 <a:cs typeface="Microsoft YaHei"/>
               </a:rPr>
-              <a:t>昇腾 NPU</a:t>
-            </a:r>
-          </a:p>
-        </p:txBody>
-      </p:sp>
-      <p:sp>
-        <p:nvSpPr>
-          <p:cNvPr id="72" name="Rectangle 71"/>
+              <a:t>NPU</a:t>
+            </a:r>
+          </a:p>
+        </p:txBody>
+      </p:sp>
+      <p:sp>
+        <p:nvSpPr>
+          <p:cNvPr id="79" name="Rectangle 78"/>
           <p:cNvSpPr/>
           <p:nvPr/>
         </p:nvSpPr>
         <p:spPr>
           <a:xfrm>
-            <a:off x="2688336" y="5870448"/>
-            <a:ext cx="9198864" cy="274320"/>
+            <a:off x="2688336" y="5815584"/>
+            <a:ext cx="9198864" cy="237744"/>
           </a:xfrm>
           <a:prstGeom prst="rect">
             <a:avLst/>
@@ -6784,14 +7122,14 @@
       </p:sp>
       <p:sp>
         <p:nvSpPr>
-          <p:cNvPr id="73" name="TextBox 72"/>
+          <p:cNvPr id="80" name="TextBox 79"/>
           <p:cNvSpPr txBox="1"/>
           <p:nvPr/>
         </p:nvSpPr>
         <p:spPr>
           <a:xfrm>
-            <a:off x="2798064" y="5870448"/>
-            <a:ext cx="9015984" cy="274320"/>
+            <a:off x="2798064" y="5815584"/>
+            <a:ext cx="9015984" cy="237744"/>
           </a:xfrm>
           <a:prstGeom prst="rect">
             <a:avLst/>
@@ -6826,14 +7164,14 @@
       </p:sp>
       <p:sp>
         <p:nvSpPr>
-          <p:cNvPr id="74" name="TextBox 73"/>
+          <p:cNvPr id="81" name="TextBox 80"/>
           <p:cNvSpPr txBox="1"/>
           <p:nvPr/>
         </p:nvSpPr>
         <p:spPr>
           <a:xfrm>
-            <a:off x="292608" y="6199632"/>
-            <a:ext cx="11612880" cy="530352"/>
+            <a:off x="292608" y="6108192"/>
+            <a:ext cx="11612880" cy="658368"/>
           </a:xfrm>
           <a:prstGeom prst="rect">
             <a:avLst/>
@@ -6861,7 +7199,7 @@
                 <a:ea typeface="Microsoft YaHei"/>
                 <a:cs typeface="Microsoft YaHei"/>
               </a:rPr>
-              <a:t>HCCL 走集合，服务模型并行。HIXL 走单边，服务 P 到 D 的 KV。按层池化目前只在 MemCache 上。</a:t>
+              <a:t>按层池化当前只接 MemCache。Conductor 只记位置，字节不经过它。HIXL 覆盖 D2D、D2H、H2D。</a:t>
             </a:r>
           </a:p>
           <a:p>
@@ -6882,7 +7220,7 @@
                 <a:ea typeface="Microsoft YaHei"/>
                 <a:cs typeface="Microsoft YaHei"/>
               </a:rPr>
-              <a:t>HCOMM 是文档里的通信基础库名。MemCache、Mooncake、YuanRong 是池后端，不是三条调用链。</a:t>
+              <a:t>MindIE 进程间的 /dev/shm 是主机共享内存里的标志位，和 CANN SHMEM 是两套。文档里的库名是 HCOMM。</a:t>
             </a:r>
           </a:p>
         </p:txBody>

</xml_diff>

<commit_message>
docs: place MemFabric beside HIXL, with device RDMA on HCCP
MemFabric does not call HIXL. Its device RDMA path posts work through
HCCP, and the host path uses ubs-comm libhcom.

Co-authored-by: 69515164-rgb <69515164-rgb@users.noreply.github.com>
</commit_message>
<xml_diff>
--- a/docs/ascend-infer-stack.pptx
+++ b/docs/ascend-infer-stack.pptx
@@ -502,7 +502,7 @@
           <a:lstStyle/>
           <a:p>
             <a:r>
-              <a:t>依据 MindIE 3.1 用户手册 Overview 与 MindIE Motor 3.1 架构说明。MindIE LLM 进入维护，官方建议新部署使用 MindIE Motor 加 vLLM-Ascend。MindIE LLM 自上而下为 Server、LLM Manager、Text Generator、Modeling。LLM Manager 内的 Engine 编排 Scheduler、Executor 和 Worker；Block Manager 管 KV 池。Executor 把调度结果下发给 Text Generator，覆盖跨节点、跨设备。Text Generator 含前处理、Generator、Sampler，并支持可插拔的并行解码。Modeling 提供 ATB Models；开发者架构说明同时支持 ACLGraph 和 ATBGraph。Motor：Coordinator 为数据面入口；Controller 与 NodeManager 为管控面；EngineServer 北向接二者，南向当前仅 vLLM。架构页写明南向接口包括 vLLM、SGLang 和 MindIE，当前版本只支持 vLLM。MindCluster 提供 Kubernetes、PD 分离 CRD 和 Operator，位于调用链外侧。CCAE 可选。CANN 组成沿用方案概述：AscendCL、GE、Runtime、算子库、HCCL、DVPP。推理运行包为 NNRT。KV 池与传输不是并列关系。AscendStoreConnector.backend 在 memcache、mooncake、yuanrong 里选一个池。MemCache 是 Motor 3.1 默认池：MetaService 管元数据，LocalService 管 DRAM。它的字节走 MemFabric，协议有 device_rdma（A2）、device_sdma（A3）、host_rdma、device_urma（950）、同节点 host_shm。Mooncake 是对象层，mooncake_master 管池。昇腾上的字节走 Ascend Direct（adxl），建在 CANN 的 HIXL 上。ASCEND_USE_ASYNC_TRANSFER 打开 HIXL 异步传输。LLM-DataDist 是 HIXL 上的 KV 接口，做链路和 pull、push，覆盖 D2D、D2H、H2D。Conductor 只是位置索引，Coordinator 用它做亲和调度，字节不经过 Conductor。YuanRong 是第三种池后端。按层池化目前只支持 MemCache。HCCL 是集合通信，服务张量并行和专家并行。HCOMM 是 HCCL 的基础库，控制面管拓扑和资源，数据面管搬运和同步。用户所说的 HCOM 对应文档名 HCOMM。CANN SHMEM（aclshmem）是算子用的对称内存。仓库示例 kv_shuffle 做跨 PE 的 KV 块拷贝，不在默认服务路径上。MindIE 的 SharedMemCommunication 和 layerwise 的 share_memory 使用主机 POSIX 共享内存传控制标志，不是 CANN SHMEM。</a:t>
+              <a:t>依据 MindIE 3.1 用户手册 Overview 与 MindIE Motor 3.1 架构说明。MindIE LLM 进入维护，官方建议新部署使用 MindIE Motor 加 vLLM-Ascend。MindIE LLM 自上而下为 Server、LLM Manager、Text Generator、Modeling。LLM Manager 内的 Engine 编排 Scheduler、Executor 和 Worker；Block Manager 管 KV 池。Executor 把调度结果下发给 Text Generator，覆盖跨节点、跨设备。Text Generator 含前处理、Generator、Sampler，并支持可插拔的并行解码。Modeling 提供 ATB Models；开发者架构说明同时支持 ACLGraph 和 ATBGraph。Motor：Coordinator 为数据面入口；Controller 与 NodeManager 为管控面；EngineServer 北向接二者，南向当前仅 vLLM。架构页写明南向接口包括 vLLM、SGLang 和 MindIE，当前版本只支持 vLLM。MindCluster 提供 Kubernetes、PD 分离 CRD 和 Operator，位于调用链外侧。CCAE 可选。CANN 组成沿用方案概述：AscendCL、GE、Runtime、算子库、HCCL、DVPP。推理运行包为 NNRT。KV 池与传输不是并列关系。AscendStoreConnector.backend 在 memcache、mooncake、yuanrong 里选一个池。MemCache 是 Motor 3.1 默认池：MetaService 管元数据，LocalService 管 DRAM。它的字节走 MemFabric，协议有 device_rdma（A2）、device_sdma（A3）、host_rdma、device_urma（950）、同节点 host_shm。MemFabric 与 HIXL 并列。memfabric_hybrid 源码中没有 hixl。device_rdma 自己建 QP，经 HCCP 的 RaSendWrV2 下发；打开设备时调用 HCCL 的 HcclCommInitClusterInfoMemConfig 取得 RDMA handle。device_sdma 走 ACL 与 HAL。host_rdma、host_tcp、host_urma 走 openEuler ubs-comm 的 libhcom.so，符号前缀是 ubs_hcom_。Mooncake 是对象层，mooncake_master 管池。昇腾上的字节走 Ascend Direct（adxl），建在 CANN 的 HIXL 上。ASCEND_USE_ASYNC_TRANSFER 打开 HIXL 异步传输。LLM-DataDist 是 HIXL 上的 KV 接口，做链路和 pull、push，覆盖 D2D、D2H、H2D。HIXL 的 FabricMem 模式由 OPTION_ENABLE_USE_FABRIC_MEM 打开，vLLM-Ascend 对应环境变量 ASCEND_ENABLE_USE_FABRIC_MEM。它是 HIXL 内部用于 A3 超节点 HCCS 上 D2RH、RH2D 的选项，不是 MemFabric 这个库。Conductor 只是位置索引，Coordinator 用它做亲和调度，字节不经过 Conductor。YuanRong 是第三种池后端。按层池化目前只支持 MemCache。HCCL 是集合通信，服务张量并行和专家并行。HCOMM 是 HCCL 的基础库，库文件 libhcomm.so，控制面管拓扑和资源，数据面管搬运和同步。用户所说的 HCOM 在 CANN 文档里对应 HCOMM。MemFabric 主机侧的 libhcom.so 来自 ubs-comm，是另一套库。CANN SHMEM（aclshmem）是算子用的对称内存。仓库示例 kv_shuffle 做跨 PE 的 KV 块拷贝，不在默认服务路径上。MindIE 的 SharedMemCommunication 和 layerwise 的 share_memory 使用主机 POSIX 共享内存传控制标志，不是 CANN SHMEM。</a:t>
             </a:r>
           </a:p>
         </p:txBody>
@@ -5621,7 +5621,7 @@
                 <a:ea typeface="Microsoft YaHei"/>
                 <a:cs typeface="Microsoft YaHei"/>
               </a:rPr>
-              <a:t>rdma、sdma、urma、host_shm。</a:t>
+              <a:t>与 HIXL 并列。rdma 经 HCCP。</a:t>
             </a:r>
           </a:p>
         </p:txBody>

</xml_diff>